<commit_message>
feat: fully offline Electron app with embedded backend + cloud sync
</commit_message>
<xml_diff>
--- a/workspace/Презентация React.pptx
+++ b/workspace/Презентация React.pptx
@@ -5,18 +5,20 @@
     <p:sldMasterId id="2147483648" r:id="rId1"/>
   </p:sldMasterIdLst>
   <p:sldIdLst>
-    <p:sldId id="256" r:id="rId7"/>
-    <p:sldId id="257" r:id="rId8"/>
-    <p:sldId id="258" r:id="rId9"/>
-    <p:sldId id="259" r:id="rId10"/>
-    <p:sldId id="260" r:id="rId11"/>
-    <p:sldId id="261" r:id="rId12"/>
-    <p:sldId id="262" r:id="rId13"/>
-    <p:sldId id="263" r:id="rId14"/>
-    <p:sldId id="264" r:id="rId15"/>
-    <p:sldId id="265" r:id="rId16"/>
+    <p:sldId id="256" r:id="rId2"/>
+    <p:sldId id="257" r:id="rId3"/>
+    <p:sldId id="258" r:id="rId4"/>
+    <p:sldId id="259" r:id="rId5"/>
+    <p:sldId id="260" r:id="rId6"/>
+    <p:sldId id="261" r:id="rId7"/>
+    <p:sldId id="262" r:id="rId8"/>
+    <p:sldId id="263" r:id="rId9"/>
+    <p:sldId id="264" r:id="rId10"/>
+    <p:sldId id="265" r:id="rId11"/>
+    <p:sldId id="266" r:id="rId12"/>
+    <p:sldId id="267" r:id="rId13"/>
   </p:sldIdLst>
-  <p:sldSz cx="12191695" cy="6858000" type="screen4x3"/>
+  <p:sldSz cx="12192000" cy="6858000"/>
   <p:notesSz cx="6858000" cy="9144000"/>
   <p:defaultTextStyle>
     <a:defPPr>
@@ -297,7 +299,7 @@
           <a:p>
             <a:fld id="{5BCAD085-E8A6-8845-BD4E-CB4CCA059FC4}" type="datetimeFigureOut">
               <a:rPr lang="en-US" smtClean="0"/>
-              <a:t>1/27/13</a:t>
+              <a:t>6/15/2026</a:t>
             </a:fld>
             <a:endParaRPr lang="en-US"/>
           </a:p>
@@ -467,7 +469,7 @@
           <a:p>
             <a:fld id="{5BCAD085-E8A6-8845-BD4E-CB4CCA059FC4}" type="datetimeFigureOut">
               <a:rPr lang="en-US" smtClean="0"/>
-              <a:t>1/27/13</a:t>
+              <a:t>6/15/2026</a:t>
             </a:fld>
             <a:endParaRPr lang="en-US"/>
           </a:p>
@@ -647,7 +649,7 @@
           <a:p>
             <a:fld id="{5BCAD085-E8A6-8845-BD4E-CB4CCA059FC4}" type="datetimeFigureOut">
               <a:rPr lang="en-US" smtClean="0"/>
-              <a:t>1/27/13</a:t>
+              <a:t>6/15/2026</a:t>
             </a:fld>
             <a:endParaRPr lang="en-US"/>
           </a:p>
@@ -817,7 +819,7 @@
           <a:p>
             <a:fld id="{5BCAD085-E8A6-8845-BD4E-CB4CCA059FC4}" type="datetimeFigureOut">
               <a:rPr lang="en-US" smtClean="0"/>
-              <a:t>1/27/13</a:t>
+              <a:t>6/15/2026</a:t>
             </a:fld>
             <a:endParaRPr lang="en-US"/>
           </a:p>
@@ -1063,7 +1065,7 @@
           <a:p>
             <a:fld id="{5BCAD085-E8A6-8845-BD4E-CB4CCA059FC4}" type="datetimeFigureOut">
               <a:rPr lang="en-US" smtClean="0"/>
-              <a:t>1/27/13</a:t>
+              <a:t>6/15/2026</a:t>
             </a:fld>
             <a:endParaRPr lang="en-US"/>
           </a:p>
@@ -1351,7 +1353,7 @@
           <a:p>
             <a:fld id="{5BCAD085-E8A6-8845-BD4E-CB4CCA059FC4}" type="datetimeFigureOut">
               <a:rPr lang="en-US" smtClean="0"/>
-              <a:t>1/27/13</a:t>
+              <a:t>6/15/2026</a:t>
             </a:fld>
             <a:endParaRPr lang="en-US"/>
           </a:p>
@@ -1773,7 +1775,7 @@
           <a:p>
             <a:fld id="{5BCAD085-E8A6-8845-BD4E-CB4CCA059FC4}" type="datetimeFigureOut">
               <a:rPr lang="en-US" smtClean="0"/>
-              <a:t>1/27/13</a:t>
+              <a:t>6/15/2026</a:t>
             </a:fld>
             <a:endParaRPr lang="en-US"/>
           </a:p>
@@ -1891,7 +1893,7 @@
           <a:p>
             <a:fld id="{5BCAD085-E8A6-8845-BD4E-CB4CCA059FC4}" type="datetimeFigureOut">
               <a:rPr lang="en-US" smtClean="0"/>
-              <a:t>1/27/13</a:t>
+              <a:t>6/15/2026</a:t>
             </a:fld>
             <a:endParaRPr lang="en-US"/>
           </a:p>
@@ -1986,7 +1988,7 @@
           <a:p>
             <a:fld id="{5BCAD085-E8A6-8845-BD4E-CB4CCA059FC4}" type="datetimeFigureOut">
               <a:rPr lang="en-US" smtClean="0"/>
-              <a:t>1/27/13</a:t>
+              <a:t>6/15/2026</a:t>
             </a:fld>
             <a:endParaRPr lang="en-US"/>
           </a:p>
@@ -2263,7 +2265,7 @@
           <a:p>
             <a:fld id="{5BCAD085-E8A6-8845-BD4E-CB4CCA059FC4}" type="datetimeFigureOut">
               <a:rPr lang="en-US" smtClean="0"/>
-              <a:t>1/27/13</a:t>
+              <a:t>6/15/2026</a:t>
             </a:fld>
             <a:endParaRPr lang="en-US"/>
           </a:p>
@@ -2516,7 +2518,7 @@
           <a:p>
             <a:fld id="{5BCAD085-E8A6-8845-BD4E-CB4CCA059FC4}" type="datetimeFigureOut">
               <a:rPr lang="en-US" smtClean="0"/>
-              <a:t>1/27/13</a:t>
+              <a:t>6/15/2026</a:t>
             </a:fld>
             <a:endParaRPr lang="en-US"/>
           </a:p>
@@ -2729,7 +2731,7 @@
           <a:p>
             <a:fld id="{5BCAD085-E8A6-8845-BD4E-CB4CCA059FC4}" type="datetimeFigureOut">
               <a:rPr lang="en-US" smtClean="0"/>
-              <a:t>1/27/13</a:t>
+              <a:t>6/15/2026</a:t>
             </a:fld>
             <a:endParaRPr lang="en-US"/>
           </a:p>
@@ -3088,12 +3090,12 @@
 </file>
 
 <file path=ppt/slides/slide1.xml><?xml version="1.0" encoding="utf-8"?>
-<p:sld xmlns:a="http://schemas.openxmlformats.org/drawingml/2006/main" xmlns:p="http://schemas.openxmlformats.org/presentationml/2006/main" xmlns:r="http://schemas.openxmlformats.org/officeDocument/2006/relationships">
+<p:sld xmlns:a="http://schemas.openxmlformats.org/drawingml/2006/main" xmlns:r="http://schemas.openxmlformats.org/officeDocument/2006/relationships" xmlns:p="http://schemas.openxmlformats.org/presentationml/2006/main">
   <p:cSld>
     <p:bg>
       <p:bgPr>
         <a:solidFill>
-          <a:srgbClr val="FFFFFF"/>
+          <a:srgbClr val="0F172A"/>
         </a:solidFill>
         <a:effectLst/>
       </p:bgPr>
@@ -3104,128 +3106,118 @@
         <p:cNvGrpSpPr/>
         <p:nvPr/>
       </p:nvGrpSpPr>
-      <p:grpSpPr/>
-      <p:sp>
-        <p:nvSpPr>
-          <p:cNvPr id="2" name="Title 1"/>
-          <p:cNvSpPr>
-            <a:spLocks noGrp="1"/>
-          </p:cNvSpPr>
-          <p:nvPr>
-            <p:ph type="title"/>
-          </p:nvPr>
-        </p:nvSpPr>
-        <p:spPr/>
-        <p:txBody>
-          <a:bodyPr wrap="square"/>
-          <a:lstStyle/>
-          <a:p>
-            <a:pPr>
-              <a:defRPr sz="3600" b="1">
-                <a:solidFill>
-                  <a:srgbClr val="1A1A1A"/>
-                </a:solidFill>
-                <a:latin typeface="Arial"/>
-              </a:defRPr>
-            </a:pPr>
-            <a:r>
-              <a:t>Зачем React?</a:t>
-            </a:r>
-          </a:p>
-        </p:txBody>
-      </p:sp>
-      <p:sp>
-        <p:nvSpPr>
-          <p:cNvPr id="3" name="Content Placeholder 2"/>
-          <p:cNvSpPr>
-            <a:spLocks noGrp="1"/>
-          </p:cNvSpPr>
-          <p:nvPr>
-            <p:ph idx="1"/>
-          </p:nvPr>
-        </p:nvSpPr>
-        <p:spPr/>
-        <p:txBody>
-          <a:bodyPr wrap="square"/>
-          <a:lstStyle/>
-          <a:p>
-            <a:pPr>
-              <a:spcAft>
-                <a:spcPts val="1200"/>
-              </a:spcAft>
-              <a:defRPr sz="2200">
-                <a:solidFill>
-                  <a:srgbClr val="333333"/>
-                </a:solidFill>
-                <a:latin typeface="Arial"/>
-              </a:defRPr>
-            </a:pPr>
-            <a:r>
-              <a:t>Ручное управление интерфейсом = спагетти-код.</a:t>
-            </a:r>
-          </a:p>
-          <a:p>
-            <a:pPr>
-              <a:spcAft>
-                <a:spcPts val="1200"/>
-              </a:spcAft>
-              <a:defRPr sz="2200">
-                <a:solidFill>
-                  <a:srgbClr val="333333"/>
-                </a:solidFill>
-                <a:latin typeface="Arial"/>
-              </a:defRPr>
-            </a:pPr>
-            <a:r>
-              <a:t>React сам решает, что перерисовать.</a:t>
-            </a:r>
-          </a:p>
-          <a:p>
-            <a:pPr>
-              <a:spcAft>
-                <a:spcPts val="1200"/>
-              </a:spcAft>
-              <a:defRPr sz="2200">
-                <a:solidFill>
-                  <a:srgbClr val="333333"/>
-                </a:solidFill>
-                <a:latin typeface="Arial"/>
-              </a:defRPr>
-            </a:pPr>
-            <a:r>
-              <a:t>Виртуальный DOM = черновик перед чистовиком.</a:t>
-            </a:r>
-          </a:p>
-          <a:p>
-            <a:pPr>
-              <a:spcAft>
-                <a:spcPts val="1200"/>
-              </a:spcAft>
-              <a:defRPr sz="2200">
-                <a:solidFill>
-                  <a:srgbClr val="333333"/>
-                </a:solidFill>
-                <a:latin typeface="Arial"/>
-              </a:defRPr>
-            </a:pPr>
-            <a:r>
-              <a:t>Меняем только то, что реально изменилось.</a:t>
-            </a:r>
-          </a:p>
-          <a:p>
-            <a:pPr>
-              <a:spcAft>
-                <a:spcPts val="1200"/>
-              </a:spcAft>
-              <a:defRPr sz="2200">
-                <a:solidFill>
-                  <a:srgbClr val="333333"/>
-                </a:solidFill>
-                <a:latin typeface="Arial"/>
-              </a:defRPr>
-            </a:pPr>
-            <a:r>
-              <a:t>Ты говоришь ЧТО нужно, а не КАК сделать.</a:t>
+      <p:grpSpPr>
+        <a:xfrm>
+          <a:off x="0" y="0"/>
+          <a:ext cx="0" cy="0"/>
+          <a:chOff x="0" y="0"/>
+          <a:chExt cx="0" cy="0"/>
+        </a:xfrm>
+      </p:grpSpPr>
+      <p:sp>
+        <p:nvSpPr>
+          <p:cNvPr id="2" name="TextBox 1"/>
+          <p:cNvSpPr txBox="1"/>
+          <p:nvPr/>
+        </p:nvSpPr>
+        <p:spPr>
+          <a:xfrm>
+            <a:off x="457200" y="2286000"/>
+            <a:ext cx="11247120" cy="1371600"/>
+          </a:xfrm>
+          <a:prstGeom prst="rect">
+            <a:avLst/>
+          </a:prstGeom>
+          <a:noFill/>
+        </p:spPr>
+        <p:txBody>
+          <a:bodyPr wrap="none">
+            <a:spAutoFit/>
+          </a:bodyPr>
+          <a:lstStyle/>
+          <a:p>
+            <a:pPr algn="ctr">
+              <a:defRPr sz="4400" b="1">
+                <a:solidFill>
+                  <a:srgbClr val="FFFFFF"/>
+                </a:solidFill>
+                <a:latin typeface="Times New Roman"/>
+              </a:defRPr>
+            </a:pPr>
+            <a:r>
+              <a:t>Обзорный доклад по React.js</a:t>
+            </a:r>
+          </a:p>
+        </p:txBody>
+      </p:sp>
+      <p:sp>
+        <p:nvSpPr>
+          <p:cNvPr id="3" name="TextBox 2"/>
+          <p:cNvSpPr txBox="1"/>
+          <p:nvPr/>
+        </p:nvSpPr>
+        <p:spPr>
+          <a:xfrm>
+            <a:off x="457200" y="3840480"/>
+            <a:ext cx="11247120" cy="914400"/>
+          </a:xfrm>
+          <a:prstGeom prst="rect">
+            <a:avLst/>
+          </a:prstGeom>
+          <a:noFill/>
+        </p:spPr>
+        <p:txBody>
+          <a:bodyPr wrap="none">
+            <a:spAutoFit/>
+          </a:bodyPr>
+          <a:lstStyle/>
+          <a:p>
+            <a:pPr algn="ctr">
+              <a:defRPr sz="2800">
+                <a:solidFill>
+                  <a:srgbClr val="94A3B8"/>
+                </a:solidFill>
+                <a:latin typeface="Times New Roman"/>
+              </a:defRPr>
+            </a:pPr>
+            <a:r>
+              <a:t>Презентация с устной защитой</a:t>
+            </a:r>
+          </a:p>
+        </p:txBody>
+      </p:sp>
+      <p:sp>
+        <p:nvSpPr>
+          <p:cNvPr id="4" name="TextBox 3"/>
+          <p:cNvSpPr txBox="1"/>
+          <p:nvPr/>
+        </p:nvSpPr>
+        <p:spPr>
+          <a:xfrm>
+            <a:off x="457200" y="4754880"/>
+            <a:ext cx="11247120" cy="548640"/>
+          </a:xfrm>
+          <a:prstGeom prst="rect">
+            <a:avLst/>
+          </a:prstGeom>
+          <a:noFill/>
+        </p:spPr>
+        <p:txBody>
+          <a:bodyPr wrap="none">
+            <a:spAutoFit/>
+          </a:bodyPr>
+          <a:lstStyle/>
+          <a:p>
+            <a:pPr algn="ctr">
+              <a:defRPr sz="2000">
+                <a:solidFill>
+                  <a:srgbClr val="94A3B8"/>
+                </a:solidFill>
+                <a:latin typeface="Times New Roman"/>
+              </a:defRPr>
+            </a:pPr>
+            <a:r>
+              <a:t>Вайман, Билялова — 2026</a:t>
             </a:r>
           </a:p>
         </p:txBody>
@@ -3239,12 +3231,12 @@
 </file>
 
 <file path=ppt/slides/slide10.xml><?xml version="1.0" encoding="utf-8"?>
-<p:sld xmlns:a="http://schemas.openxmlformats.org/drawingml/2006/main" xmlns:p="http://schemas.openxmlformats.org/presentationml/2006/main" xmlns:r="http://schemas.openxmlformats.org/officeDocument/2006/relationships">
+<p:sld xmlns:a="http://schemas.openxmlformats.org/drawingml/2006/main" xmlns:r="http://schemas.openxmlformats.org/officeDocument/2006/relationships" xmlns:p="http://schemas.openxmlformats.org/presentationml/2006/main">
   <p:cSld>
     <p:bg>
       <p:bgPr>
         <a:solidFill>
-          <a:srgbClr val="FFFFFF"/>
+          <a:srgbClr val="0F172A"/>
         </a:solidFill>
         <a:effectLst/>
       </p:bgPr>
@@ -3255,96 +3247,302 @@
         <p:cNvGrpSpPr/>
         <p:nvPr/>
       </p:nvGrpSpPr>
-      <p:grpSpPr/>
-      <p:sp>
-        <p:nvSpPr>
-          <p:cNvPr id="2" name="Title 1"/>
-          <p:cNvSpPr>
-            <a:spLocks noGrp="1"/>
-          </p:cNvSpPr>
-          <p:nvPr>
-            <p:ph type="title"/>
-          </p:nvPr>
-        </p:nvSpPr>
-        <p:spPr/>
-        <p:txBody>
-          <a:bodyPr wrap="square"/>
-          <a:lstStyle/>
-          <a:p>
-            <a:pPr>
-              <a:defRPr sz="3600" b="1">
-                <a:solidFill>
-                  <a:srgbClr val="1A1A1A"/>
-                </a:solidFill>
-                <a:latin typeface="Arial"/>
-              </a:defRPr>
-            </a:pPr>
-            <a:r>
-              <a:t>Итог</a:t>
-            </a:r>
-          </a:p>
-        </p:txBody>
-      </p:sp>
-      <p:sp>
-        <p:nvSpPr>
-          <p:cNvPr id="3" name="Content Placeholder 2"/>
-          <p:cNvSpPr>
-            <a:spLocks noGrp="1"/>
-          </p:cNvSpPr>
-          <p:nvPr>
-            <p:ph idx="1"/>
-          </p:nvPr>
-        </p:nvSpPr>
-        <p:spPr/>
-        <p:txBody>
-          <a:bodyPr wrap="square"/>
+      <p:grpSpPr>
+        <a:xfrm>
+          <a:off x="0" y="0"/>
+          <a:ext cx="0" cy="0"/>
+          <a:chOff x="0" y="0"/>
+          <a:chExt cx="0" cy="0"/>
+        </a:xfrm>
+      </p:grpSpPr>
+      <p:sp>
+        <p:nvSpPr>
+          <p:cNvPr id="2" name="TextBox 1"/>
+          <p:cNvSpPr txBox="1"/>
+          <p:nvPr/>
+        </p:nvSpPr>
+        <p:spPr>
+          <a:xfrm>
+            <a:off x="457200" y="365760"/>
+            <a:ext cx="11247120" cy="731520"/>
+          </a:xfrm>
+          <a:prstGeom prst="rect">
+            <a:avLst/>
+          </a:prstGeom>
+          <a:noFill/>
+        </p:spPr>
+        <p:txBody>
+          <a:bodyPr wrap="none">
+            <a:spAutoFit/>
+          </a:bodyPr>
+          <a:lstStyle/>
+          <a:p>
+            <a:pPr algn="l">
+              <a:defRPr sz="3200" b="1">
+                <a:solidFill>
+                  <a:srgbClr val="38BDF8"/>
+                </a:solidFill>
+                <a:latin typeface="Times New Roman"/>
+              </a:defRPr>
+            </a:pPr>
+            <a:r>
+              <a:t>8. Роутинг в SPA</a:t>
+            </a:r>
+          </a:p>
+        </p:txBody>
+      </p:sp>
+      <p:sp>
+        <p:nvSpPr>
+          <p:cNvPr id="3" name="TextBox 2"/>
+          <p:cNvSpPr txBox="1"/>
+          <p:nvPr/>
+        </p:nvSpPr>
+        <p:spPr>
+          <a:xfrm>
+            <a:off x="457200" y="1097280"/>
+            <a:ext cx="11247120" cy="5303520"/>
+          </a:xfrm>
+          <a:prstGeom prst="rect">
+            <a:avLst/>
+          </a:prstGeom>
+          <a:noFill/>
+        </p:spPr>
+        <p:txBody>
+          <a:bodyPr wrap="square">
+            <a:spAutoFit/>
+          </a:bodyPr>
           <a:lstStyle/>
           <a:p>
             <a:pPr>
               <a:spcAft>
-                <a:spcPts val="1200"/>
+                <a:spcPts val="800"/>
               </a:spcAft>
-              <a:defRPr sz="2200">
-                <a:solidFill>
-                  <a:srgbClr val="333333"/>
-                </a:solidFill>
-                <a:latin typeface="Arial"/>
-              </a:defRPr>
-            </a:pPr>
-            <a:r>
-              <a:t>React рисует интерфейс за тебя — ты только описываешь результат.</a:t>
+              <a:defRPr sz="1800">
+                <a:solidFill>
+                  <a:srgbClr val="FFFFFF"/>
+                </a:solidFill>
+                <a:latin typeface="Times New Roman"/>
+              </a:defRPr>
+            </a:pPr>
+            <a:r>
+              <a:t>SPA — одностраничное приложение. Код загружается один раз, навигация без перезагрузки.</a:t>
             </a:r>
           </a:p>
           <a:p>
             <a:pPr>
               <a:spcAft>
-                <a:spcPts val="1200"/>
+                <a:spcPts val="800"/>
               </a:spcAft>
-              <a:defRPr sz="2200">
-                <a:solidFill>
-                  <a:srgbClr val="333333"/>
-                </a:solidFill>
-                <a:latin typeface="Arial"/>
-              </a:defRPr>
-            </a:pPr>
-            <a:r>
-              <a:t>Компоненты и хуки делают код понятным и тестируемым.</a:t>
+              <a:defRPr sz="1800">
+                <a:solidFill>
+                  <a:srgbClr val="FFFFFF"/>
+                </a:solidFill>
+                <a:latin typeface="Times New Roman"/>
+              </a:defRPr>
+            </a:pPr>
+            <a:r>
+              <a:t>Роутинг — сопоставление URL с компонентами. Стандарт: react-router-dom.</a:t>
             </a:r>
           </a:p>
           <a:p>
             <a:pPr>
               <a:spcAft>
-                <a:spcPts val="1200"/>
+                <a:spcPts val="800"/>
               </a:spcAft>
-              <a:defRPr sz="2200">
-                <a:solidFill>
-                  <a:srgbClr val="333333"/>
-                </a:solidFill>
-                <a:latin typeface="Arial"/>
-              </a:defRPr>
-            </a:pPr>
-            <a:r>
-              <a:t>Роутинг + API = полноценное одностраничное приложение.</a:t>
+              <a:defRPr sz="1800">
+                <a:solidFill>
+                  <a:srgbClr val="FFFFFF"/>
+                </a:solidFill>
+                <a:latin typeface="Times New Roman"/>
+              </a:defRPr>
+            </a:pPr>
+            <a:endParaRPr/>
+          </a:p>
+          <a:p>
+            <a:pPr>
+              <a:spcAft>
+                <a:spcPts val="800"/>
+              </a:spcAft>
+              <a:defRPr sz="1800">
+                <a:solidFill>
+                  <a:srgbClr val="FFFFFF"/>
+                </a:solidFill>
+                <a:latin typeface="Times New Roman"/>
+              </a:defRPr>
+            </a:pPr>
+            <a:r>
+              <a:t>BrowserRouter — обёртка через History API</a:t>
+            </a:r>
+          </a:p>
+          <a:p>
+            <a:pPr>
+              <a:spcAft>
+                <a:spcPts val="800"/>
+              </a:spcAft>
+              <a:defRPr sz="1800">
+                <a:solidFill>
+                  <a:srgbClr val="FFFFFF"/>
+                </a:solidFill>
+                <a:latin typeface="Times New Roman"/>
+              </a:defRPr>
+            </a:pPr>
+            <a:r>
+              <a:t>Routes — контейнер маршрутов</a:t>
+            </a:r>
+          </a:p>
+          <a:p>
+            <a:pPr>
+              <a:spcAft>
+                <a:spcPts val="800"/>
+              </a:spcAft>
+              <a:defRPr sz="1800">
+                <a:solidFill>
+                  <a:srgbClr val="FFFFFF"/>
+                </a:solidFill>
+                <a:latin typeface="Times New Roman"/>
+              </a:defRPr>
+            </a:pPr>
+            <a:r>
+              <a:t>Route — шаблон пути + компонент</a:t>
+            </a:r>
+          </a:p>
+          <a:p>
+            <a:pPr>
+              <a:spcAft>
+                <a:spcPts val="800"/>
+              </a:spcAft>
+              <a:defRPr sz="1800">
+                <a:solidFill>
+                  <a:srgbClr val="FFFFFF"/>
+                </a:solidFill>
+                <a:latin typeface="Times New Roman"/>
+              </a:defRPr>
+            </a:pPr>
+            <a:endParaRPr/>
+          </a:p>
+          <a:p>
+            <a:pPr>
+              <a:spcAft>
+                <a:spcPts val="800"/>
+              </a:spcAft>
+              <a:defRPr sz="1800">
+                <a:solidFill>
+                  <a:srgbClr val="FFFFFF"/>
+                </a:solidFill>
+                <a:latin typeface="Times New Roman"/>
+              </a:defRPr>
+            </a:pPr>
+            <a:r>
+              <a:t>Link vs &lt;a&gt;: &lt;a&gt; перезагружает страницу. Link меняет URL через History API без перезагрузки.</a:t>
+            </a:r>
+          </a:p>
+          <a:p>
+            <a:pPr>
+              <a:spcAft>
+                <a:spcPts val="800"/>
+              </a:spcAft>
+              <a:defRPr sz="1800">
+                <a:solidFill>
+                  <a:srgbClr val="FFFFFF"/>
+                </a:solidFill>
+                <a:latin typeface="Times New Roman"/>
+              </a:defRPr>
+            </a:pPr>
+            <a:r>
+              <a:t>Динамические параметры: /user/:id — доступны через useParams().</a:t>
+            </a:r>
+          </a:p>
+        </p:txBody>
+      </p:sp>
+      <p:sp>
+        <p:nvSpPr>
+          <p:cNvPr id="4" name="Rectangle 3"/>
+          <p:cNvSpPr/>
+          <p:nvPr/>
+        </p:nvSpPr>
+        <p:spPr>
+          <a:xfrm>
+            <a:off x="457200" y="5303520"/>
+            <a:ext cx="91440" cy="914400"/>
+          </a:xfrm>
+          <a:prstGeom prst="rect">
+            <a:avLst/>
+          </a:prstGeom>
+          <a:solidFill>
+            <a:srgbClr val="F87171"/>
+          </a:solidFill>
+          <a:ln>
+            <a:noFill/>
+          </a:ln>
+        </p:spPr>
+        <p:style>
+          <a:lnRef idx="1">
+            <a:schemeClr val="accent1"/>
+          </a:lnRef>
+          <a:fillRef idx="3">
+            <a:schemeClr val="accent1"/>
+          </a:fillRef>
+          <a:effectRef idx="2">
+            <a:schemeClr val="accent1"/>
+          </a:effectRef>
+          <a:fontRef idx="minor">
+            <a:schemeClr val="lt1"/>
+          </a:fontRef>
+        </p:style>
+        <p:txBody>
+          <a:bodyPr rtlCol="0" anchor="ctr"/>
+          <a:lstStyle/>
+          <a:p>
+            <a:pPr algn="ctr"/>
+            <a:endParaRPr/>
+          </a:p>
+        </p:txBody>
+      </p:sp>
+      <p:sp>
+        <p:nvSpPr>
+          <p:cNvPr id="5" name="TextBox 4"/>
+          <p:cNvSpPr txBox="1"/>
+          <p:nvPr/>
+        </p:nvSpPr>
+        <p:spPr>
+          <a:xfrm>
+            <a:off x="640080" y="5303520"/>
+            <a:ext cx="10972800" cy="914400"/>
+          </a:xfrm>
+          <a:prstGeom prst="rect">
+            <a:avLst/>
+          </a:prstGeom>
+          <a:noFill/>
+        </p:spPr>
+        <p:txBody>
+          <a:bodyPr wrap="square">
+            <a:spAutoFit/>
+          </a:bodyPr>
+          <a:lstStyle/>
+          <a:p>
+            <a:pPr>
+              <a:defRPr sz="1800" b="1">
+                <a:solidFill>
+                  <a:srgbClr val="F87171"/>
+                </a:solidFill>
+                <a:latin typeface="Times New Roman"/>
+              </a:defRPr>
+            </a:pPr>
+            <a:r>
+              <a:t>Ошибка: использование &lt;a&gt; в SPA</a:t>
+            </a:r>
+          </a:p>
+          <a:p>
+            <a:pPr>
+              <a:defRPr sz="1600">
+                <a:solidFill>
+                  <a:srgbClr val="FFFFFF"/>
+                </a:solidFill>
+                <a:latin typeface="Times New Roman"/>
+              </a:defRPr>
+            </a:pPr>
+            <a:r>
+              <a:t>Каждый клик по &lt;a&gt; разрушает состояние и перезагружает приложение.</a:t>
             </a:r>
           </a:p>
         </p:txBody>
@@ -3357,13 +3555,13 @@
 </p:sld>
 </file>
 
-<file path=ppt/slides/slide2.xml><?xml version="1.0" encoding="utf-8"?>
-<p:sld xmlns:a="http://schemas.openxmlformats.org/drawingml/2006/main" xmlns:p="http://schemas.openxmlformats.org/presentationml/2006/main" xmlns:r="http://schemas.openxmlformats.org/officeDocument/2006/relationships">
+<file path=ppt/slides/slide11.xml><?xml version="1.0" encoding="utf-8"?>
+<p:sld xmlns:a="http://schemas.openxmlformats.org/drawingml/2006/main" xmlns:r="http://schemas.openxmlformats.org/officeDocument/2006/relationships" xmlns:p="http://schemas.openxmlformats.org/presentationml/2006/main">
   <p:cSld>
     <p:bg>
       <p:bgPr>
         <a:solidFill>
-          <a:srgbClr val="FFFFFF"/>
+          <a:srgbClr val="0F172A"/>
         </a:solidFill>
         <a:effectLst/>
       </p:bgPr>
@@ -3374,128 +3572,682 @@
         <p:cNvGrpSpPr/>
         <p:nvPr/>
       </p:nvGrpSpPr>
-      <p:grpSpPr/>
-      <p:sp>
-        <p:nvSpPr>
-          <p:cNvPr id="2" name="Title 1"/>
-          <p:cNvSpPr>
-            <a:spLocks noGrp="1"/>
-          </p:cNvSpPr>
-          <p:nvPr>
-            <p:ph type="title"/>
-          </p:nvPr>
-        </p:nvSpPr>
-        <p:spPr/>
-        <p:txBody>
-          <a:bodyPr wrap="square"/>
-          <a:lstStyle/>
-          <a:p>
-            <a:pPr>
-              <a:defRPr sz="3600" b="1">
-                <a:solidFill>
-                  <a:srgbClr val="1A1A1A"/>
-                </a:solidFill>
-                <a:latin typeface="Arial"/>
-              </a:defRPr>
-            </a:pPr>
-            <a:r>
-              <a:t>Структура проекта</a:t>
-            </a:r>
-          </a:p>
-        </p:txBody>
-      </p:sp>
-      <p:sp>
-        <p:nvSpPr>
-          <p:cNvPr id="3" name="Content Placeholder 2"/>
-          <p:cNvSpPr>
-            <a:spLocks noGrp="1"/>
-          </p:cNvSpPr>
-          <p:nvPr>
-            <p:ph idx="1"/>
-          </p:nvPr>
-        </p:nvSpPr>
-        <p:spPr/>
-        <p:txBody>
-          <a:bodyPr wrap="square"/>
+      <p:grpSpPr>
+        <a:xfrm>
+          <a:off x="0" y="0"/>
+          <a:ext cx="0" cy="0"/>
+          <a:chOff x="0" y="0"/>
+          <a:chExt cx="0" cy="0"/>
+        </a:xfrm>
+      </p:grpSpPr>
+      <p:sp>
+        <p:nvSpPr>
+          <p:cNvPr id="2" name="TextBox 1"/>
+          <p:cNvSpPr txBox="1"/>
+          <p:nvPr/>
+        </p:nvSpPr>
+        <p:spPr>
+          <a:xfrm>
+            <a:off x="457200" y="365760"/>
+            <a:ext cx="11247120" cy="731520"/>
+          </a:xfrm>
+          <a:prstGeom prst="rect">
+            <a:avLst/>
+          </a:prstGeom>
+          <a:noFill/>
+        </p:spPr>
+        <p:txBody>
+          <a:bodyPr wrap="none">
+            <a:spAutoFit/>
+          </a:bodyPr>
+          <a:lstStyle/>
+          <a:p>
+            <a:pPr algn="l">
+              <a:defRPr sz="3200" b="1">
+                <a:solidFill>
+                  <a:srgbClr val="38BDF8"/>
+                </a:solidFill>
+                <a:latin typeface="Times New Roman"/>
+              </a:defRPr>
+            </a:pPr>
+            <a:r>
+              <a:t>9. Запросы к API</a:t>
+            </a:r>
+          </a:p>
+        </p:txBody>
+      </p:sp>
+      <p:sp>
+        <p:nvSpPr>
+          <p:cNvPr id="3" name="TextBox 2"/>
+          <p:cNvSpPr txBox="1"/>
+          <p:nvPr/>
+        </p:nvSpPr>
+        <p:spPr>
+          <a:xfrm>
+            <a:off x="457200" y="1097280"/>
+            <a:ext cx="11247120" cy="2267287"/>
+          </a:xfrm>
+          <a:prstGeom prst="rect">
+            <a:avLst/>
+          </a:prstGeom>
+          <a:noFill/>
+        </p:spPr>
+        <p:txBody>
+          <a:bodyPr wrap="square">
+            <a:spAutoFit/>
+          </a:bodyPr>
           <a:lstStyle/>
           <a:p>
             <a:pPr>
               <a:spcAft>
-                <a:spcPts val="1200"/>
+                <a:spcPts val="800"/>
               </a:spcAft>
-              <a:defRPr sz="2200">
-                <a:solidFill>
-                  <a:srgbClr val="333333"/>
-                </a:solidFill>
-                <a:latin typeface="Arial"/>
-              </a:defRPr>
-            </a:pPr>
-            <a:r>
-              <a:t>Vite или CRA — создаём проект одной командой.</a:t>
+              <a:defRPr sz="1800">
+                <a:solidFill>
+                  <a:srgbClr val="FFFFFF"/>
+                </a:solidFill>
+                <a:latin typeface="Times New Roman"/>
+              </a:defRPr>
+            </a:pPr>
+            <a:r>
+              <a:rPr dirty="0"/>
+              <a:t>API — </a:t>
+            </a:r>
+            <a:r>
+              <a:rPr dirty="0" err="1"/>
+              <a:t>интерфейс</a:t>
+            </a:r>
+            <a:r>
+              <a:rPr dirty="0"/>
+              <a:t> </a:t>
+            </a:r>
+            <a:r>
+              <a:rPr dirty="0" err="1"/>
+              <a:t>взаимодействия</a:t>
+            </a:r>
+            <a:r>
+              <a:rPr dirty="0"/>
+              <a:t> </a:t>
+            </a:r>
+            <a:r>
+              <a:rPr dirty="0" err="1"/>
+              <a:t>фронтенда</a:t>
+            </a:r>
+            <a:r>
+              <a:rPr dirty="0"/>
+              <a:t> с </a:t>
+            </a:r>
+            <a:r>
+              <a:rPr dirty="0" err="1"/>
+              <a:t>бэкендом</a:t>
+            </a:r>
+            <a:r>
+              <a:rPr dirty="0"/>
+              <a:t>. </a:t>
+            </a:r>
+            <a:r>
+              <a:rPr dirty="0" err="1"/>
+              <a:t>Формат</a:t>
+            </a:r>
+            <a:r>
+              <a:rPr dirty="0"/>
+              <a:t> </a:t>
+            </a:r>
+            <a:r>
+              <a:rPr dirty="0" err="1"/>
+              <a:t>данных</a:t>
+            </a:r>
+            <a:r>
+              <a:rPr dirty="0"/>
+              <a:t> — JSON.</a:t>
             </a:r>
           </a:p>
           <a:p>
             <a:pPr>
               <a:spcAft>
-                <a:spcPts val="1200"/>
+                <a:spcPts val="800"/>
               </a:spcAft>
-              <a:defRPr sz="2200">
-                <a:solidFill>
-                  <a:srgbClr val="333333"/>
-                </a:solidFill>
-                <a:latin typeface="Arial"/>
-              </a:defRPr>
-            </a:pPr>
-            <a:r>
-              <a:t>main.jsx → вставляет приложение в &lt;div id="root"&gt;.</a:t>
-            </a:r>
+              <a:defRPr sz="1800">
+                <a:solidFill>
+                  <a:srgbClr val="FFFFFF"/>
+                </a:solidFill>
+                <a:latin typeface="Times New Roman"/>
+              </a:defRPr>
+            </a:pPr>
+            <a:r>
+              <a:rPr dirty="0" err="1"/>
+              <a:t>Где</a:t>
+            </a:r>
+            <a:r>
+              <a:rPr dirty="0"/>
+              <a:t> </a:t>
+            </a:r>
+            <a:r>
+              <a:rPr dirty="0" err="1"/>
+              <a:t>выполнять</a:t>
+            </a:r>
+            <a:r>
+              <a:rPr dirty="0"/>
+              <a:t>: </a:t>
+            </a:r>
+            <a:r>
+              <a:rPr dirty="0" err="1"/>
+              <a:t>внутри</a:t>
+            </a:r>
+            <a:r>
+              <a:rPr dirty="0"/>
+              <a:t> </a:t>
+            </a:r>
+            <a:r>
+              <a:rPr dirty="0" err="1"/>
+              <a:t>useEffect</a:t>
+            </a:r>
+            <a:r>
+              <a:rPr dirty="0"/>
+              <a:t> с </a:t>
+            </a:r>
+            <a:r>
+              <a:rPr dirty="0" err="1"/>
+              <a:t>пустым</a:t>
+            </a:r>
+            <a:r>
+              <a:rPr dirty="0"/>
+              <a:t> </a:t>
+            </a:r>
+            <a:r>
+              <a:rPr dirty="0" err="1"/>
+              <a:t>массивом</a:t>
+            </a:r>
+            <a:r>
+              <a:rPr dirty="0"/>
+              <a:t> []. </a:t>
+            </a:r>
+            <a:r>
+              <a:rPr dirty="0" err="1"/>
+              <a:t>Запрос</a:t>
+            </a:r>
+            <a:r>
+              <a:rPr dirty="0"/>
+              <a:t> — </a:t>
+            </a:r>
+            <a:r>
+              <a:rPr dirty="0" err="1"/>
+              <a:t>побочный</a:t>
+            </a:r>
+            <a:r>
+              <a:rPr dirty="0"/>
+              <a:t> </a:t>
+            </a:r>
+            <a:r>
+              <a:rPr dirty="0" err="1"/>
+              <a:t>эффект</a:t>
+            </a:r>
+            <a:r>
+              <a:rPr dirty="0" smtClean="0"/>
+              <a:t>.</a:t>
+            </a:r>
+            <a:endParaRPr dirty="0"/>
           </a:p>
           <a:p>
             <a:pPr>
               <a:spcAft>
-                <a:spcPts val="1200"/>
+                <a:spcPts val="800"/>
               </a:spcAft>
-              <a:defRPr sz="2200">
-                <a:solidFill>
-                  <a:srgbClr val="333333"/>
-                </a:solidFill>
-                <a:latin typeface="Arial"/>
-              </a:defRPr>
-            </a:pPr>
-            <a:r>
-              <a:t>div#root — пустая рамка, внутри которой живёт React.</a:t>
+              <a:defRPr sz="1800">
+                <a:solidFill>
+                  <a:srgbClr val="FFFFFF"/>
+                </a:solidFill>
+                <a:latin typeface="Times New Roman"/>
+              </a:defRPr>
+            </a:pPr>
+            <a:r>
+              <a:rPr dirty="0" err="1"/>
+              <a:t>Три</a:t>
+            </a:r>
+            <a:r>
+              <a:rPr dirty="0"/>
+              <a:t> </a:t>
+            </a:r>
+            <a:r>
+              <a:rPr dirty="0" err="1"/>
+              <a:t>состояния</a:t>
+            </a:r>
+            <a:r>
+              <a:rPr dirty="0"/>
+              <a:t>:</a:t>
             </a:r>
           </a:p>
           <a:p>
             <a:pPr>
               <a:spcAft>
-                <a:spcPts val="1200"/>
+                <a:spcPts val="800"/>
               </a:spcAft>
-              <a:defRPr sz="2200">
-                <a:solidFill>
-                  <a:srgbClr val="333333"/>
-                </a:solidFill>
-                <a:latin typeface="Arial"/>
-              </a:defRPr>
-            </a:pPr>
-            <a:r>
-              <a:t>Dev-сервер: меняешь код → видишь результат мгновенно.</a:t>
-            </a:r>
+              <a:defRPr sz="1800">
+                <a:solidFill>
+                  <a:srgbClr val="FFFFFF"/>
+                </a:solidFill>
+                <a:latin typeface="Times New Roman"/>
+              </a:defRPr>
+            </a:pPr>
+            <a:r>
+              <a:rPr dirty="0"/>
+              <a:t>  • loading — </a:t>
+            </a:r>
+            <a:r>
+              <a:rPr dirty="0" err="1"/>
+              <a:t>идёт</a:t>
+            </a:r>
+            <a:r>
+              <a:rPr dirty="0"/>
+              <a:t> </a:t>
+            </a:r>
+            <a:r>
+              <a:rPr dirty="0" err="1"/>
+              <a:t>загрузка</a:t>
+            </a:r>
+            <a:r>
+              <a:rPr dirty="0"/>
+              <a:t>, </a:t>
+            </a:r>
+            <a:r>
+              <a:rPr dirty="0" err="1"/>
+              <a:t>показываем</a:t>
+            </a:r>
+            <a:r>
+              <a:rPr dirty="0"/>
+              <a:t> </a:t>
+            </a:r>
+            <a:r>
+              <a:rPr dirty="0" err="1"/>
+              <a:t>спиннер</a:t>
+            </a:r>
+            <a:endParaRPr dirty="0"/>
           </a:p>
           <a:p>
             <a:pPr>
               <a:spcAft>
-                <a:spcPts val="1200"/>
+                <a:spcPts val="800"/>
               </a:spcAft>
-              <a:defRPr sz="2200">
-                <a:solidFill>
-                  <a:srgbClr val="333333"/>
-                </a:solidFill>
-                <a:latin typeface="Arial"/>
-              </a:defRPr>
-            </a:pPr>
-            <a:r>
-              <a:t>Production: код сжимается и разбивается на части.</a:t>
+              <a:defRPr sz="1800">
+                <a:solidFill>
+                  <a:srgbClr val="FFFFFF"/>
+                </a:solidFill>
+                <a:latin typeface="Times New Roman"/>
+              </a:defRPr>
+            </a:pPr>
+            <a:r>
+              <a:rPr dirty="0"/>
+              <a:t>  • data — </a:t>
+            </a:r>
+            <a:r>
+              <a:rPr dirty="0" err="1"/>
+              <a:t>данные</a:t>
+            </a:r>
+            <a:r>
+              <a:rPr dirty="0"/>
+              <a:t> </a:t>
+            </a:r>
+            <a:r>
+              <a:rPr dirty="0" err="1"/>
+              <a:t>получены</a:t>
+            </a:r>
+            <a:r>
+              <a:rPr dirty="0"/>
+              <a:t>, </a:t>
+            </a:r>
+            <a:r>
+              <a:rPr dirty="0" err="1"/>
+              <a:t>показываем</a:t>
+            </a:r>
+            <a:r>
+              <a:rPr dirty="0"/>
+              <a:t> </a:t>
+            </a:r>
+            <a:r>
+              <a:rPr dirty="0" err="1"/>
+              <a:t>контент</a:t>
+            </a:r>
+            <a:endParaRPr dirty="0"/>
+          </a:p>
+          <a:p>
+            <a:pPr>
+              <a:spcAft>
+                <a:spcPts val="800"/>
+              </a:spcAft>
+              <a:defRPr sz="1800">
+                <a:solidFill>
+                  <a:srgbClr val="FFFFFF"/>
+                </a:solidFill>
+                <a:latin typeface="Times New Roman"/>
+              </a:defRPr>
+            </a:pPr>
+            <a:r>
+              <a:rPr dirty="0"/>
+              <a:t>  • error — </a:t>
+            </a:r>
+            <a:r>
+              <a:rPr dirty="0" err="1"/>
+              <a:t>ошибка</a:t>
+            </a:r>
+            <a:r>
+              <a:rPr dirty="0"/>
+              <a:t> </a:t>
+            </a:r>
+            <a:r>
+              <a:rPr dirty="0" err="1"/>
+              <a:t>сети</a:t>
+            </a:r>
+            <a:r>
+              <a:rPr dirty="0"/>
+              <a:t>/</a:t>
+            </a:r>
+            <a:r>
+              <a:rPr dirty="0" err="1"/>
+              <a:t>сервера</a:t>
+            </a:r>
+            <a:r>
+              <a:rPr dirty="0"/>
+              <a:t>, </a:t>
+            </a:r>
+            <a:r>
+              <a:rPr dirty="0" err="1"/>
+              <a:t>показываем</a:t>
+            </a:r>
+            <a:r>
+              <a:rPr dirty="0"/>
+              <a:t> </a:t>
+            </a:r>
+            <a:r>
+              <a:rPr dirty="0" err="1"/>
+              <a:t>сообщение</a:t>
+            </a:r>
+            <a:endParaRPr dirty="0"/>
+          </a:p>
+        </p:txBody>
+      </p:sp>
+      <p:sp>
+        <p:nvSpPr>
+          <p:cNvPr id="4" name="Rectangle 3"/>
+          <p:cNvSpPr/>
+          <p:nvPr/>
+        </p:nvSpPr>
+        <p:spPr>
+          <a:xfrm>
+            <a:off x="457200" y="3749039"/>
+            <a:ext cx="5719313" cy="2853961"/>
+          </a:xfrm>
+          <a:prstGeom prst="rect">
+            <a:avLst/>
+          </a:prstGeom>
+          <a:solidFill>
+            <a:srgbClr val="020617"/>
+          </a:solidFill>
+          <a:ln>
+            <a:noFill/>
+          </a:ln>
+        </p:spPr>
+        <p:style>
+          <a:lnRef idx="1">
+            <a:schemeClr val="accent1"/>
+          </a:lnRef>
+          <a:fillRef idx="3">
+            <a:schemeClr val="accent1"/>
+          </a:fillRef>
+          <a:effectRef idx="2">
+            <a:schemeClr val="accent1"/>
+          </a:effectRef>
+          <a:fontRef idx="minor">
+            <a:schemeClr val="lt1"/>
+          </a:fontRef>
+        </p:style>
+        <p:txBody>
+          <a:bodyPr rtlCol="0" anchor="ctr"/>
+          <a:lstStyle/>
+          <a:p>
+            <a:pPr algn="ctr"/>
+            <a:endParaRPr/>
+          </a:p>
+        </p:txBody>
+      </p:sp>
+      <p:sp>
+        <p:nvSpPr>
+          <p:cNvPr id="5" name="TextBox 4"/>
+          <p:cNvSpPr txBox="1"/>
+          <p:nvPr/>
+        </p:nvSpPr>
+        <p:spPr>
+          <a:xfrm>
+            <a:off x="640080" y="3740679"/>
+            <a:ext cx="10881360" cy="2862322"/>
+          </a:xfrm>
+          <a:prstGeom prst="rect">
+            <a:avLst/>
+          </a:prstGeom>
+          <a:noFill/>
+        </p:spPr>
+        <p:txBody>
+          <a:bodyPr wrap="square">
+            <a:spAutoFit/>
+          </a:bodyPr>
+          <a:lstStyle/>
+          <a:p>
+            <a:pPr>
+              <a:defRPr sz="1400">
+                <a:solidFill>
+                  <a:srgbClr val="34D399"/>
+                </a:solidFill>
+                <a:latin typeface="Consolas"/>
+              </a:defRPr>
+            </a:pPr>
+            <a:r>
+              <a:rPr sz="1200" dirty="0" err="1"/>
+              <a:t>useEffect</a:t>
+            </a:r>
+            <a:r>
+              <a:rPr sz="1200" dirty="0"/>
+              <a:t>(() =&gt; {</a:t>
+            </a:r>
+            <a:br>
+              <a:rPr sz="1200" dirty="0"/>
+            </a:br>
+            <a:r>
+              <a:rPr sz="1200" dirty="0"/>
+              <a:t>  </a:t>
+            </a:r>
+            <a:r>
+              <a:rPr sz="1200" dirty="0" err="1"/>
+              <a:t>const</a:t>
+            </a:r>
+            <a:r>
+              <a:rPr sz="1200" dirty="0"/>
+              <a:t> </a:t>
+            </a:r>
+            <a:r>
+              <a:rPr sz="1200" dirty="0" err="1"/>
+              <a:t>fetchData</a:t>
+            </a:r>
+            <a:r>
+              <a:rPr sz="1200" dirty="0"/>
+              <a:t> = </a:t>
+            </a:r>
+            <a:r>
+              <a:rPr sz="1200" dirty="0" err="1"/>
+              <a:t>async</a:t>
+            </a:r>
+            <a:r>
+              <a:rPr sz="1200" dirty="0"/>
+              <a:t> () =&gt; {</a:t>
+            </a:r>
+            <a:br>
+              <a:rPr sz="1200" dirty="0"/>
+            </a:br>
+            <a:r>
+              <a:rPr sz="1200" dirty="0"/>
+              <a:t>    try {</a:t>
+            </a:r>
+            <a:br>
+              <a:rPr sz="1200" dirty="0"/>
+            </a:br>
+            <a:r>
+              <a:rPr sz="1200" dirty="0"/>
+              <a:t>      </a:t>
+            </a:r>
+            <a:r>
+              <a:rPr sz="1200" dirty="0" err="1"/>
+              <a:t>setLoading</a:t>
+            </a:r>
+            <a:r>
+              <a:rPr sz="1200" dirty="0"/>
+              <a:t>(true);</a:t>
+            </a:r>
+            <a:br>
+              <a:rPr sz="1200" dirty="0"/>
+            </a:br>
+            <a:r>
+              <a:rPr sz="1200" dirty="0"/>
+              <a:t>      </a:t>
+            </a:r>
+            <a:r>
+              <a:rPr sz="1200" dirty="0" err="1"/>
+              <a:t>const</a:t>
+            </a:r>
+            <a:r>
+              <a:rPr sz="1200" dirty="0"/>
+              <a:t> res = await fetch("/</a:t>
+            </a:r>
+            <a:r>
+              <a:rPr sz="1200" dirty="0" err="1"/>
+              <a:t>api</a:t>
+            </a:r>
+            <a:r>
+              <a:rPr sz="1200" dirty="0"/>
+              <a:t>/data");</a:t>
+            </a:r>
+            <a:br>
+              <a:rPr sz="1200" dirty="0"/>
+            </a:br>
+            <a:r>
+              <a:rPr sz="1200" dirty="0"/>
+              <a:t>      </a:t>
+            </a:r>
+            <a:r>
+              <a:rPr sz="1200" dirty="0" err="1"/>
+              <a:t>const</a:t>
+            </a:r>
+            <a:r>
+              <a:rPr sz="1200" dirty="0"/>
+              <a:t> result = await </a:t>
+            </a:r>
+            <a:r>
+              <a:rPr sz="1200" dirty="0" err="1"/>
+              <a:t>res.json</a:t>
+            </a:r>
+            <a:r>
+              <a:rPr sz="1200" dirty="0"/>
+              <a:t>();</a:t>
+            </a:r>
+            <a:br>
+              <a:rPr sz="1200" dirty="0"/>
+            </a:br>
+            <a:r>
+              <a:rPr sz="1200" dirty="0"/>
+              <a:t>      </a:t>
+            </a:r>
+            <a:r>
+              <a:rPr sz="1200" dirty="0" err="1"/>
+              <a:t>setData</a:t>
+            </a:r>
+            <a:r>
+              <a:rPr sz="1200" dirty="0"/>
+              <a:t>(result);</a:t>
+            </a:r>
+            <a:br>
+              <a:rPr sz="1200" dirty="0"/>
+            </a:br>
+            <a:r>
+              <a:rPr sz="1200" dirty="0"/>
+              <a:t>    } catch (err) {</a:t>
+            </a:r>
+            <a:br>
+              <a:rPr sz="1200" dirty="0"/>
+            </a:br>
+            <a:r>
+              <a:rPr sz="1200" dirty="0"/>
+              <a:t>      </a:t>
+            </a:r>
+            <a:r>
+              <a:rPr sz="1200" dirty="0" err="1"/>
+              <a:t>setError</a:t>
+            </a:r>
+            <a:r>
+              <a:rPr sz="1200" dirty="0"/>
+              <a:t>(</a:t>
+            </a:r>
+            <a:r>
+              <a:rPr sz="1200" dirty="0" err="1"/>
+              <a:t>err.message</a:t>
+            </a:r>
+            <a:r>
+              <a:rPr sz="1200" dirty="0"/>
+              <a:t>);</a:t>
+            </a:r>
+            <a:br>
+              <a:rPr sz="1200" dirty="0"/>
+            </a:br>
+            <a:r>
+              <a:rPr sz="1200" dirty="0"/>
+              <a:t>    } finally {</a:t>
+            </a:r>
+            <a:br>
+              <a:rPr sz="1200" dirty="0"/>
+            </a:br>
+            <a:r>
+              <a:rPr sz="1200" dirty="0"/>
+              <a:t>      </a:t>
+            </a:r>
+            <a:r>
+              <a:rPr sz="1200" dirty="0" err="1"/>
+              <a:t>setLoading</a:t>
+            </a:r>
+            <a:r>
+              <a:rPr sz="1200" dirty="0"/>
+              <a:t>(false);</a:t>
+            </a:r>
+            <a:br>
+              <a:rPr sz="1200" dirty="0"/>
+            </a:br>
+            <a:r>
+              <a:rPr sz="1200" dirty="0"/>
+              <a:t>    }</a:t>
+            </a:r>
+            <a:br>
+              <a:rPr sz="1200" dirty="0"/>
+            </a:br>
+            <a:r>
+              <a:rPr sz="1200" dirty="0"/>
+              <a:t>  };</a:t>
+            </a:r>
+            <a:br>
+              <a:rPr sz="1200" dirty="0"/>
+            </a:br>
+            <a:r>
+              <a:rPr sz="1200" dirty="0"/>
+              <a:t>  </a:t>
+            </a:r>
+            <a:r>
+              <a:rPr sz="1200" dirty="0" err="1"/>
+              <a:t>fetchData</a:t>
+            </a:r>
+            <a:r>
+              <a:rPr sz="1200" dirty="0"/>
+              <a:t>();</a:t>
+            </a:r>
+            <a:br>
+              <a:rPr sz="1200" dirty="0"/>
+            </a:br>
+            <a:r>
+              <a:rPr sz="1200" dirty="0"/>
+              <a:t>}, []);</a:t>
             </a:r>
           </a:p>
         </p:txBody>
@@ -3508,13 +4260,13 @@
 </p:sld>
 </file>
 
-<file path=ppt/slides/slide3.xml><?xml version="1.0" encoding="utf-8"?>
-<p:sld xmlns:a="http://schemas.openxmlformats.org/drawingml/2006/main" xmlns:p="http://schemas.openxmlformats.org/presentationml/2006/main" xmlns:r="http://schemas.openxmlformats.org/officeDocument/2006/relationships">
+<file path=ppt/slides/slide12.xml><?xml version="1.0" encoding="utf-8"?>
+<p:sld xmlns:a="http://schemas.openxmlformats.org/drawingml/2006/main" xmlns:r="http://schemas.openxmlformats.org/officeDocument/2006/relationships" xmlns:p="http://schemas.openxmlformats.org/presentationml/2006/main">
   <p:cSld>
     <p:bg>
       <p:bgPr>
         <a:solidFill>
-          <a:srgbClr val="FFFFFF"/>
+          <a:srgbClr val="0F172A"/>
         </a:solidFill>
         <a:effectLst/>
       </p:bgPr>
@@ -3525,177 +4277,156 @@
         <p:cNvGrpSpPr/>
         <p:nvPr/>
       </p:nvGrpSpPr>
-      <p:grpSpPr/>
-      <p:sp>
-        <p:nvSpPr>
-          <p:cNvPr id="2" name="Title 1"/>
-          <p:cNvSpPr>
-            <a:spLocks noGrp="1"/>
-          </p:cNvSpPr>
-          <p:nvPr>
-            <p:ph type="title"/>
-          </p:nvPr>
-        </p:nvSpPr>
-        <p:spPr/>
-        <p:txBody>
-          <a:bodyPr wrap="square"/>
-          <a:lstStyle/>
-          <a:p>
-            <a:pPr>
-              <a:defRPr sz="3600" b="1">
-                <a:solidFill>
-                  <a:srgbClr val="1A1A1A"/>
-                </a:solidFill>
-                <a:latin typeface="Arial"/>
-              </a:defRPr>
-            </a:pPr>
-            <a:r>
-              <a:t>JSX — HTML внутри JavaScript</a:t>
-            </a:r>
-          </a:p>
-        </p:txBody>
-      </p:sp>
-      <p:sp>
-        <p:nvSpPr>
-          <p:cNvPr id="3" name="Content Placeholder 2"/>
-          <p:cNvSpPr>
-            <a:spLocks noGrp="1"/>
-          </p:cNvSpPr>
-          <p:nvPr>
-            <p:ph idx="1"/>
-          </p:nvPr>
-        </p:nvSpPr>
-        <p:spPr/>
-        <p:txBody>
-          <a:bodyPr wrap="square"/>
-          <a:lstStyle/>
-          <a:p>
-            <a:pPr>
-              <a:spcAft>
-                <a:spcPts val="1200"/>
-              </a:spcAft>
-              <a:defRPr sz="2200">
-                <a:solidFill>
-                  <a:srgbClr val="333333"/>
-                </a:solidFill>
-                <a:latin typeface="Arial"/>
-              </a:defRPr>
-            </a:pPr>
-            <a:r>
-              <a:t>Выглядит как HTML, но это JavaScript.</a:t>
-            </a:r>
-          </a:p>
-          <a:p>
-            <a:pPr>
-              <a:spcAft>
-                <a:spcPts val="1200"/>
-              </a:spcAft>
-              <a:defRPr sz="2200">
-                <a:solidFill>
-                  <a:srgbClr val="333333"/>
-                </a:solidFill>
-                <a:latin typeface="Arial"/>
-              </a:defRPr>
-            </a:pPr>
-            <a:r>
-              <a:t>За кулисами: JSX → React.createElement(...).</a:t>
-            </a:r>
-          </a:p>
-          <a:p>
-            <a:pPr>
-              <a:spcAft>
-                <a:spcPts val="1200"/>
-              </a:spcAft>
-              <a:defRPr sz="2200">
-                <a:solidFill>
-                  <a:srgbClr val="333333"/>
-                </a:solidFill>
-                <a:latin typeface="Arial"/>
-              </a:defRPr>
-            </a:pPr>
-            <a:r>
-              <a:t>Правила:</a:t>
-            </a:r>
-          </a:p>
-          <a:p>
-            <a:pPr lvl="1">
-              <a:spcAft>
-                <a:spcPts val="1200"/>
-              </a:spcAft>
-              <a:defRPr sz="2200">
-                <a:solidFill>
-                  <a:srgbClr val="333333"/>
-                </a:solidFill>
-                <a:latin typeface="Arial"/>
-              </a:defRPr>
-            </a:pPr>
-            <a:r>
-              <a:t>  → Один корневой элемент (или фрагмент &lt;&gt;...&lt;/&gt;).</a:t>
-            </a:r>
-          </a:p>
-          <a:p>
-            <a:pPr lvl="1">
-              <a:spcAft>
-                <a:spcPts val="1200"/>
-              </a:spcAft>
-              <a:defRPr sz="2200">
-                <a:solidFill>
-                  <a:srgbClr val="333333"/>
-                </a:solidFill>
-                <a:latin typeface="Arial"/>
-              </a:defRPr>
-            </a:pPr>
-            <a:r>
-              <a:t>  → camelCase: className, onClick, htmlFor.</a:t>
-            </a:r>
-          </a:p>
-          <a:p>
-            <a:pPr lvl="1">
-              <a:spcAft>
-                <a:spcPts val="1200"/>
-              </a:spcAft>
-              <a:defRPr sz="2200">
-                <a:solidFill>
-                  <a:srgbClr val="333333"/>
-                </a:solidFill>
-                <a:latin typeface="Arial"/>
-              </a:defRPr>
-            </a:pPr>
-            <a:r>
-              <a:t>  → Все теги закрыты: &lt;img /&gt;, &lt;input /&gt;.</a:t>
-            </a:r>
-          </a:p>
-          <a:p>
-            <a:pPr lvl="1">
-              <a:spcAft>
-                <a:spcPts val="1200"/>
-              </a:spcAft>
-              <a:defRPr sz="2200">
-                <a:solidFill>
-                  <a:srgbClr val="333333"/>
-                </a:solidFill>
-                <a:latin typeface="Arial"/>
-              </a:defRPr>
-            </a:pPr>
-            <a:r>
-              <a:t>  → Переменные в фигурных скобках: {name}.</a:t>
-            </a:r>
-          </a:p>
-          <a:p>
-            <a:pPr>
-              <a:spcAft>
-                <a:spcPts val="1200"/>
-              </a:spcAft>
-              <a:defRPr sz="2200">
-                <a:solidFill>
-                  <a:srgbClr val="333333"/>
-                </a:solidFill>
-                <a:latin typeface="Arial"/>
-              </a:defRPr>
-            </a:pPr>
-            <a:r>
-              <a:t>Фрагменты спасают от лишних обёрточных div.</a:t>
-            </a:r>
+      <p:grpSpPr>
+        <a:xfrm>
+          <a:off x="0" y="0"/>
+          <a:ext cx="0" cy="0"/>
+          <a:chOff x="0" y="0"/>
+          <a:chExt cx="0" cy="0"/>
+        </a:xfrm>
+      </p:grpSpPr>
+      <p:sp>
+        <p:nvSpPr>
+          <p:cNvPr id="2" name="TextBox 1"/>
+          <p:cNvSpPr txBox="1"/>
+          <p:nvPr/>
+        </p:nvSpPr>
+        <p:spPr>
+          <a:xfrm>
+            <a:off x="457200" y="2286000"/>
+            <a:ext cx="11247120" cy="1371600"/>
+          </a:xfrm>
+          <a:prstGeom prst="rect">
+            <a:avLst/>
+          </a:prstGeom>
+          <a:noFill/>
+        </p:spPr>
+        <p:txBody>
+          <a:bodyPr wrap="none">
+            <a:spAutoFit/>
+          </a:bodyPr>
+          <a:lstStyle/>
+          <a:p>
+            <a:pPr algn="ctr">
+              <a:defRPr sz="4400" b="1">
+                <a:solidFill>
+                  <a:srgbClr val="FFFFFF"/>
+                </a:solidFill>
+                <a:latin typeface="Times New Roman"/>
+              </a:defRPr>
+            </a:pPr>
+            <a:r>
+              <a:t>Спасибо за внимание!</a:t>
+            </a:r>
+          </a:p>
+        </p:txBody>
+      </p:sp>
+      <p:sp>
+        <p:nvSpPr>
+          <p:cNvPr id="3" name="TextBox 2"/>
+          <p:cNvSpPr txBox="1"/>
+          <p:nvPr/>
+        </p:nvSpPr>
+        <p:spPr>
+          <a:xfrm>
+            <a:off x="457200" y="3840480"/>
+            <a:ext cx="11247120" cy="914400"/>
+          </a:xfrm>
+          <a:prstGeom prst="rect">
+            <a:avLst/>
+          </a:prstGeom>
+          <a:noFill/>
+        </p:spPr>
+        <p:txBody>
+          <a:bodyPr wrap="none">
+            <a:spAutoFit/>
+          </a:bodyPr>
+          <a:lstStyle/>
+          <a:p>
+            <a:pPr algn="ctr">
+              <a:defRPr sz="2800">
+                <a:solidFill>
+                  <a:srgbClr val="94A3B8"/>
+                </a:solidFill>
+                <a:latin typeface="Times New Roman"/>
+              </a:defRPr>
+            </a:pPr>
+            <a:r>
+              <a:t>Вопросы?</a:t>
+            </a:r>
+          </a:p>
+        </p:txBody>
+      </p:sp>
+      <p:sp>
+        <p:nvSpPr>
+          <p:cNvPr id="4" name="TextBox 3"/>
+          <p:cNvSpPr txBox="1"/>
+          <p:nvPr/>
+        </p:nvSpPr>
+        <p:spPr>
+          <a:xfrm>
+            <a:off x="457200" y="4572000"/>
+            <a:ext cx="11247120" cy="914400"/>
+          </a:xfrm>
+          <a:prstGeom prst="rect">
+            <a:avLst/>
+          </a:prstGeom>
+          <a:noFill/>
+        </p:spPr>
+        <p:txBody>
+          <a:bodyPr wrap="none">
+            <a:spAutoFit/>
+          </a:bodyPr>
+          <a:lstStyle/>
+          <a:p>
+            <a:pPr algn="ctr">
+              <a:defRPr sz="1800">
+                <a:solidFill>
+                  <a:srgbClr val="94A3B8"/>
+                </a:solidFill>
+                <a:latin typeface="Times New Roman"/>
+              </a:defRPr>
+            </a:pPr>
+            <a:r>
+              <a:rPr dirty="0"/>
+              <a:t>React.js — </a:t>
+            </a:r>
+            <a:r>
+              <a:t>декларативная</a:t>
+            </a:r>
+            <a:r>
+              <a:rPr dirty="0"/>
+              <a:t> </a:t>
+            </a:r>
+            <a:r>
+              <a:rPr dirty="0" err="1"/>
+              <a:t>библиотека</a:t>
+            </a:r>
+            <a:r>
+              <a:rPr dirty="0"/>
+              <a:t> </a:t>
+            </a:r>
+            <a:r>
+              <a:rPr dirty="0" err="1"/>
+              <a:t>для</a:t>
+            </a:r>
+            <a:r>
+              <a:rPr dirty="0"/>
+              <a:t> </a:t>
+            </a:r>
+            <a:r>
+              <a:rPr dirty="0" err="1"/>
+              <a:t>построения</a:t>
+            </a:r>
+            <a:r>
+              <a:rPr dirty="0"/>
+              <a:t> </a:t>
+            </a:r>
+            <a:r>
+              <a:rPr dirty="0" err="1"/>
+              <a:t>интерфейсов</a:t>
+            </a:r>
+            <a:endParaRPr dirty="0"/>
           </a:p>
         </p:txBody>
       </p:sp>
@@ -3707,13 +4438,13 @@
 </p:sld>
 </file>
 
-<file path=ppt/slides/slide4.xml><?xml version="1.0" encoding="utf-8"?>
-<p:sld xmlns:a="http://schemas.openxmlformats.org/drawingml/2006/main" xmlns:p="http://schemas.openxmlformats.org/presentationml/2006/main" xmlns:r="http://schemas.openxmlformats.org/officeDocument/2006/relationships">
+<file path=ppt/slides/slide2.xml><?xml version="1.0" encoding="utf-8"?>
+<p:sld xmlns:a="http://schemas.openxmlformats.org/drawingml/2006/main" xmlns:r="http://schemas.openxmlformats.org/officeDocument/2006/relationships" xmlns:p="http://schemas.openxmlformats.org/presentationml/2006/main">
   <p:cSld>
     <p:bg>
       <p:bgPr>
         <a:solidFill>
-          <a:srgbClr val="FFFFFF"/>
+          <a:srgbClr val="0F172A"/>
         </a:solidFill>
         <a:effectLst/>
       </p:bgPr>
@@ -3724,128 +4455,213 @@
         <p:cNvGrpSpPr/>
         <p:nvPr/>
       </p:nvGrpSpPr>
-      <p:grpSpPr/>
-      <p:sp>
-        <p:nvSpPr>
-          <p:cNvPr id="2" name="Title 1"/>
-          <p:cNvSpPr>
-            <a:spLocks noGrp="1"/>
-          </p:cNvSpPr>
-          <p:nvPr>
-            <p:ph type="title"/>
-          </p:nvPr>
-        </p:nvSpPr>
-        <p:spPr/>
-        <p:txBody>
-          <a:bodyPr wrap="square"/>
-          <a:lstStyle/>
-          <a:p>
-            <a:pPr>
-              <a:defRPr sz="3600" b="1">
-                <a:solidFill>
-                  <a:srgbClr val="1A1A1A"/>
-                </a:solidFill>
-                <a:latin typeface="Arial"/>
-              </a:defRPr>
-            </a:pPr>
-            <a:r>
-              <a:t>Компоненты — кирпичики</a:t>
-            </a:r>
-          </a:p>
-        </p:txBody>
-      </p:sp>
-      <p:sp>
-        <p:nvSpPr>
-          <p:cNvPr id="3" name="Content Placeholder 2"/>
-          <p:cNvSpPr>
-            <a:spLocks noGrp="1"/>
-          </p:cNvSpPr>
-          <p:nvPr>
-            <p:ph idx="1"/>
-          </p:nvPr>
-        </p:nvSpPr>
-        <p:spPr/>
-        <p:txBody>
-          <a:bodyPr wrap="square"/>
+      <p:grpSpPr>
+        <a:xfrm>
+          <a:off x="0" y="0"/>
+          <a:ext cx="0" cy="0"/>
+          <a:chOff x="0" y="0"/>
+          <a:chExt cx="0" cy="0"/>
+        </a:xfrm>
+      </p:grpSpPr>
+      <p:sp>
+        <p:nvSpPr>
+          <p:cNvPr id="2" name="TextBox 1"/>
+          <p:cNvSpPr txBox="1"/>
+          <p:nvPr/>
+        </p:nvSpPr>
+        <p:spPr>
+          <a:xfrm>
+            <a:off x="457200" y="365760"/>
+            <a:ext cx="11247120" cy="731520"/>
+          </a:xfrm>
+          <a:prstGeom prst="rect">
+            <a:avLst/>
+          </a:prstGeom>
+          <a:noFill/>
+        </p:spPr>
+        <p:txBody>
+          <a:bodyPr wrap="none">
+            <a:spAutoFit/>
+          </a:bodyPr>
+          <a:lstStyle/>
+          <a:p>
+            <a:pPr algn="l">
+              <a:defRPr sz="3200" b="1">
+                <a:solidFill>
+                  <a:srgbClr val="38BDF8"/>
+                </a:solidFill>
+                <a:latin typeface="Times New Roman"/>
+              </a:defRPr>
+            </a:pPr>
+            <a:r>
+              <a:t>Содержание</a:t>
+            </a:r>
+          </a:p>
+        </p:txBody>
+      </p:sp>
+      <p:sp>
+        <p:nvSpPr>
+          <p:cNvPr id="3" name="TextBox 2"/>
+          <p:cNvSpPr txBox="1"/>
+          <p:nvPr/>
+        </p:nvSpPr>
+        <p:spPr>
+          <a:xfrm>
+            <a:off x="457200" y="1097280"/>
+            <a:ext cx="11247120" cy="5303520"/>
+          </a:xfrm>
+          <a:prstGeom prst="rect">
+            <a:avLst/>
+          </a:prstGeom>
+          <a:noFill/>
+        </p:spPr>
+        <p:txBody>
+          <a:bodyPr wrap="square">
+            <a:spAutoFit/>
+          </a:bodyPr>
           <a:lstStyle/>
           <a:p>
             <a:pPr>
               <a:spcAft>
-                <a:spcPts val="1200"/>
+                <a:spcPts val="1000"/>
               </a:spcAft>
-              <a:defRPr sz="2200">
-                <a:solidFill>
-                  <a:srgbClr val="333333"/>
-                </a:solidFill>
-                <a:latin typeface="Arial"/>
-              </a:defRPr>
-            </a:pPr>
-            <a:r>
-              <a:t>Функциональные: функция + хуки = современный стандарт.</a:t>
+              <a:defRPr sz="1800">
+                <a:solidFill>
+                  <a:srgbClr val="FFFFFF"/>
+                </a:solidFill>
+                <a:latin typeface="Times New Roman"/>
+              </a:defRPr>
+            </a:pPr>
+            <a:r>
+              <a:t>• Назначение React. Виртуальный DOM. Императивный и декларативный подходы</a:t>
             </a:r>
           </a:p>
           <a:p>
             <a:pPr>
               <a:spcAft>
-                <a:spcPts val="1200"/>
+                <a:spcPts val="1000"/>
               </a:spcAft>
-              <a:defRPr sz="2200">
-                <a:solidFill>
-                  <a:srgbClr val="333333"/>
-                </a:solidFill>
-                <a:latin typeface="Arial"/>
-              </a:defRPr>
-            </a:pPr>
-            <a:r>
-              <a:t>Классовые: устаревают, почти не используются.</a:t>
+              <a:defRPr sz="1800">
+                <a:solidFill>
+                  <a:srgbClr val="FFFFFF"/>
+                </a:solidFill>
+                <a:latin typeface="Times New Roman"/>
+              </a:defRPr>
+            </a:pPr>
+            <a:r>
+              <a:t>• Структура проекта (CRA / Vite). Точка входа, процесс сборки, dev и production</a:t>
             </a:r>
           </a:p>
           <a:p>
             <a:pPr>
               <a:spcAft>
-                <a:spcPts val="1200"/>
+                <a:spcPts val="1000"/>
               </a:spcAft>
-              <a:defRPr sz="2200">
-                <a:solidFill>
-                  <a:srgbClr val="333333"/>
-                </a:solidFill>
-                <a:latin typeface="Arial"/>
-              </a:defRPr>
-            </a:pPr>
-            <a:r>
-              <a:t>Один компонент = одна задача.</a:t>
+              <a:defRPr sz="1800">
+                <a:solidFill>
+                  <a:srgbClr val="FFFFFF"/>
+                </a:solidFill>
+                <a:latin typeface="Times New Roman"/>
+              </a:defRPr>
+            </a:pPr>
+            <a:r>
+              <a:t>• Связь JSX и React.createElement. Правила написания. Проблема без фрагмента</a:t>
             </a:r>
           </a:p>
           <a:p>
             <a:pPr>
               <a:spcAft>
-                <a:spcPts val="1200"/>
+                <a:spcPts val="1000"/>
               </a:spcAft>
-              <a:defRPr sz="2200">
-                <a:solidFill>
-                  <a:srgbClr val="333333"/>
-                </a:solidFill>
-                <a:latin typeface="Arial"/>
-              </a:defRPr>
-            </a:pPr>
-            <a:r>
-              <a:t>Разрастается? Разбивай на мелкие части.</a:t>
+              <a:defRPr sz="1800">
+                <a:solidFill>
+                  <a:srgbClr val="FFFFFF"/>
+                </a:solidFill>
+                <a:latin typeface="Times New Roman"/>
+              </a:defRPr>
+            </a:pPr>
+            <a:r>
+              <a:t>• Функциональные и классовые компоненты. SRP. Декомпозиция</a:t>
             </a:r>
           </a:p>
           <a:p>
             <a:pPr>
               <a:spcAft>
-                <a:spcPts val="1200"/>
+                <a:spcPts val="1000"/>
               </a:spcAft>
-              <a:defRPr sz="2200" b="1">
-                <a:solidFill>
-                  <a:srgbClr val="0066CC"/>
-                </a:solidFill>
-                <a:latin typeface="Arial"/>
-              </a:defRPr>
-            </a:pPr>
-            <a:r>
-              <a:t>[!] Не создавай компонент внутри другого — теряется память.</a:t>
+              <a:defRPr sz="1800">
+                <a:solidFill>
+                  <a:srgbClr val="FFFFFF"/>
+                </a:solidFill>
+                <a:latin typeface="Times New Roman"/>
+              </a:defRPr>
+            </a:pPr>
+            <a:r>
+              <a:t>• Однонаправленный поток данных. Пропсы. Деструктуризация</a:t>
+            </a:r>
+          </a:p>
+          <a:p>
+            <a:pPr>
+              <a:spcAft>
+                <a:spcPts val="1000"/>
+              </a:spcAft>
+              <a:defRPr sz="1800">
+                <a:solidFill>
+                  <a:srgbClr val="FFFFFF"/>
+                </a:solidFill>
+                <a:latin typeface="Times New Roman"/>
+              </a:defRPr>
+            </a:pPr>
+            <a:r>
+              <a:t>• Хук useState. Состояние vs пропсы. Асинхронность. Мутация</a:t>
+            </a:r>
+          </a:p>
+          <a:p>
+            <a:pPr>
+              <a:spcAft>
+                <a:spcPts val="1000"/>
+              </a:spcAft>
+              <a:defRPr sz="1800">
+                <a:solidFill>
+                  <a:srgbClr val="FFFFFF"/>
+                </a:solidFill>
+                <a:latin typeface="Times New Roman"/>
+              </a:defRPr>
+            </a:pPr>
+            <a:r>
+              <a:t>• Хук useEffect. Массив зависимостей. Cleanup. Бесконечный цикл</a:t>
+            </a:r>
+          </a:p>
+          <a:p>
+            <a:pPr>
+              <a:spcAft>
+                <a:spcPts val="1000"/>
+              </a:spcAft>
+              <a:defRPr sz="1800">
+                <a:solidFill>
+                  <a:srgbClr val="FFFFFF"/>
+                </a:solidFill>
+                <a:latin typeface="Times New Roman"/>
+              </a:defRPr>
+            </a:pPr>
+            <a:r>
+              <a:t>• Роутинг в SPA. BrowserRouter, Routes, Route. Link vs &lt;a&gt;</a:t>
+            </a:r>
+          </a:p>
+          <a:p>
+            <a:pPr>
+              <a:spcAft>
+                <a:spcPts val="1000"/>
+              </a:spcAft>
+              <a:defRPr sz="1800">
+                <a:solidFill>
+                  <a:srgbClr val="FFFFFF"/>
+                </a:solidFill>
+                <a:latin typeface="Times New Roman"/>
+              </a:defRPr>
+            </a:pPr>
+            <a:r>
+              <a:t>• Запросы к API. Где выполнять. Состояния loading / data / error</a:t>
             </a:r>
           </a:p>
         </p:txBody>
@@ -3858,13 +4674,13 @@
 </p:sld>
 </file>
 
-<file path=ppt/slides/slide5.xml><?xml version="1.0" encoding="utf-8"?>
-<p:sld xmlns:a="http://schemas.openxmlformats.org/drawingml/2006/main" xmlns:p="http://schemas.openxmlformats.org/presentationml/2006/main" xmlns:r="http://schemas.openxmlformats.org/officeDocument/2006/relationships">
+<file path=ppt/slides/slide3.xml><?xml version="1.0" encoding="utf-8"?>
+<p:sld xmlns:a="http://schemas.openxmlformats.org/drawingml/2006/main" xmlns:r="http://schemas.openxmlformats.org/officeDocument/2006/relationships" xmlns:p="http://schemas.openxmlformats.org/presentationml/2006/main">
   <p:cSld>
     <p:bg>
       <p:bgPr>
         <a:solidFill>
-          <a:srgbClr val="FFFFFF"/>
+          <a:srgbClr val="0F172A"/>
         </a:solidFill>
         <a:effectLst/>
       </p:bgPr>
@@ -3875,128 +4691,225 @@
         <p:cNvGrpSpPr/>
         <p:nvPr/>
       </p:nvGrpSpPr>
-      <p:grpSpPr/>
-      <p:sp>
-        <p:nvSpPr>
-          <p:cNvPr id="2" name="Title 1"/>
-          <p:cNvSpPr>
-            <a:spLocks noGrp="1"/>
-          </p:cNvSpPr>
-          <p:nvPr>
-            <p:ph type="title"/>
-          </p:nvPr>
-        </p:nvSpPr>
-        <p:spPr/>
-        <p:txBody>
-          <a:bodyPr wrap="square"/>
-          <a:lstStyle/>
-          <a:p>
-            <a:pPr>
-              <a:defRPr sz="3600" b="1">
-                <a:solidFill>
-                  <a:srgbClr val="1A1A1A"/>
-                </a:solidFill>
-                <a:latin typeface="Arial"/>
-              </a:defRPr>
-            </a:pPr>
-            <a:r>
-              <a:t>Пропсы — данные сверху вниз</a:t>
-            </a:r>
-          </a:p>
-        </p:txBody>
-      </p:sp>
-      <p:sp>
-        <p:nvSpPr>
-          <p:cNvPr id="3" name="Content Placeholder 2"/>
-          <p:cNvSpPr>
-            <a:spLocks noGrp="1"/>
-          </p:cNvSpPr>
-          <p:nvPr>
-            <p:ph idx="1"/>
-          </p:nvPr>
-        </p:nvSpPr>
-        <p:spPr/>
-        <p:txBody>
-          <a:bodyPr wrap="square"/>
+      <p:grpSpPr>
+        <a:xfrm>
+          <a:off x="0" y="0"/>
+          <a:ext cx="0" cy="0"/>
+          <a:chOff x="0" y="0"/>
+          <a:chExt cx="0" cy="0"/>
+        </a:xfrm>
+      </p:grpSpPr>
+      <p:sp>
+        <p:nvSpPr>
+          <p:cNvPr id="2" name="TextBox 1"/>
+          <p:cNvSpPr txBox="1"/>
+          <p:nvPr/>
+        </p:nvSpPr>
+        <p:spPr>
+          <a:xfrm>
+            <a:off x="457200" y="365760"/>
+            <a:ext cx="11247120" cy="731520"/>
+          </a:xfrm>
+          <a:prstGeom prst="rect">
+            <a:avLst/>
+          </a:prstGeom>
+          <a:noFill/>
+        </p:spPr>
+        <p:txBody>
+          <a:bodyPr wrap="none">
+            <a:spAutoFit/>
+          </a:bodyPr>
+          <a:lstStyle/>
+          <a:p>
+            <a:pPr algn="l">
+              <a:defRPr sz="3200" b="1">
+                <a:solidFill>
+                  <a:srgbClr val="38BDF8"/>
+                </a:solidFill>
+                <a:latin typeface="Times New Roman"/>
+              </a:defRPr>
+            </a:pPr>
+            <a:r>
+              <a:t>1. Назначение React. Виртуальный DOM</a:t>
+            </a:r>
+          </a:p>
+        </p:txBody>
+      </p:sp>
+      <p:sp>
+        <p:nvSpPr>
+          <p:cNvPr id="3" name="TextBox 2"/>
+          <p:cNvSpPr txBox="1"/>
+          <p:nvPr/>
+        </p:nvSpPr>
+        <p:spPr>
+          <a:xfrm>
+            <a:off x="457200" y="1097280"/>
+            <a:ext cx="11247120" cy="5303520"/>
+          </a:xfrm>
+          <a:prstGeom prst="rect">
+            <a:avLst/>
+          </a:prstGeom>
+          <a:noFill/>
+        </p:spPr>
+        <p:txBody>
+          <a:bodyPr wrap="square">
+            <a:spAutoFit/>
+          </a:bodyPr>
           <a:lstStyle/>
           <a:p>
             <a:pPr>
               <a:spcAft>
-                <a:spcPts val="1200"/>
+                <a:spcPts val="800"/>
               </a:spcAft>
-              <a:defRPr sz="2200">
-                <a:solidFill>
-                  <a:srgbClr val="333333"/>
-                </a:solidFill>
-                <a:latin typeface="Arial"/>
-              </a:defRPr>
-            </a:pPr>
-            <a:r>
-              <a:t>Родитель передаёт детям пропсы.</a:t>
+              <a:defRPr sz="2000">
+                <a:solidFill>
+                  <a:srgbClr val="FFFFFF"/>
+                </a:solidFill>
+                <a:latin typeface="Times New Roman"/>
+              </a:defRPr>
+            </a:pPr>
+            <a:r>
+              <a:t>React — библиотека JavaScript для построения пользовательских интерфейсов. Решает проблему сложности управления DOM при частых обновлениях.</a:t>
             </a:r>
           </a:p>
           <a:p>
             <a:pPr>
               <a:spcAft>
-                <a:spcPts val="1200"/>
+                <a:spcPts val="800"/>
               </a:spcAft>
-              <a:defRPr sz="2200">
-                <a:solidFill>
-                  <a:srgbClr val="333333"/>
-                </a:solidFill>
-                <a:latin typeface="Arial"/>
-              </a:defRPr>
-            </a:pPr>
-            <a:r>
-              <a:t>Пропсы только для чтения — изменить нельзя.</a:t>
-            </a:r>
+              <a:defRPr sz="2000">
+                <a:solidFill>
+                  <a:srgbClr val="FFFFFF"/>
+                </a:solidFill>
+                <a:latin typeface="Times New Roman"/>
+              </a:defRPr>
+            </a:pPr>
+            <a:endParaRPr/>
           </a:p>
           <a:p>
             <a:pPr>
               <a:spcAft>
-                <a:spcPts val="1200"/>
+                <a:spcPts val="800"/>
               </a:spcAft>
-              <a:defRPr sz="2200">
-                <a:solidFill>
-                  <a:srgbClr val="333333"/>
-                </a:solidFill>
-                <a:latin typeface="Arial"/>
-              </a:defRPr>
-            </a:pPr>
-            <a:r>
-              <a:t>Деструктуризация: function Card({ title, image }).</a:t>
+              <a:defRPr sz="2000">
+                <a:solidFill>
+                  <a:srgbClr val="FFFFFF"/>
+                </a:solidFill>
+                <a:latin typeface="Times New Roman"/>
+              </a:defRPr>
+            </a:pPr>
+            <a:r>
+              <a:t>Виртуальный DOM — легковесная копия реального DOM в виде JS-объектов. React сравнивает новое дерево со старым через реконсиляцию и применяет минимальные изменения.</a:t>
             </a:r>
           </a:p>
           <a:p>
             <a:pPr>
               <a:spcAft>
-                <a:spcPts val="1200"/>
+                <a:spcPts val="800"/>
               </a:spcAft>
-              <a:defRPr sz="2200">
-                <a:solidFill>
-                  <a:srgbClr val="333333"/>
-                </a:solidFill>
-                <a:latin typeface="Arial"/>
-              </a:defRPr>
-            </a:pPr>
-            <a:r>
-              <a:t>Значения по умолчанию: { type = "button" }.</a:t>
-            </a:r>
+              <a:defRPr sz="2000">
+                <a:solidFill>
+                  <a:srgbClr val="FFFFFF"/>
+                </a:solidFill>
+                <a:latin typeface="Times New Roman"/>
+              </a:defRPr>
+            </a:pPr>
+            <a:endParaRPr/>
           </a:p>
           <a:p>
             <a:pPr>
               <a:spcAft>
-                <a:spcPts val="1200"/>
+                <a:spcPts val="800"/>
               </a:spcAft>
-              <a:defRPr sz="2200">
-                <a:solidFill>
-                  <a:srgbClr val="333333"/>
-                </a:solidFill>
-                <a:latin typeface="Arial"/>
-              </a:defRPr>
-            </a:pPr>
-            <a:r>
-              <a:t>Ошибка? Ищи в пропсах или в состоянии — других вариантов нет.</a:t>
+              <a:defRPr sz="2000">
+                <a:solidFill>
+                  <a:srgbClr val="FFFFFF"/>
+                </a:solidFill>
+                <a:latin typeface="Times New Roman"/>
+              </a:defRPr>
+            </a:pPr>
+            <a:r>
+              <a:t>Императивный подход — «как сделать» (пошаговые инструкции). Декларативный подход — «что должно быть» (описание результата). React — декларативен.</a:t>
+            </a:r>
+          </a:p>
+        </p:txBody>
+      </p:sp>
+      <p:sp>
+        <p:nvSpPr>
+          <p:cNvPr id="4" name="Rectangle 3"/>
+          <p:cNvSpPr/>
+          <p:nvPr/>
+        </p:nvSpPr>
+        <p:spPr>
+          <a:xfrm>
+            <a:off x="457200" y="5303520"/>
+            <a:ext cx="11247120" cy="1097280"/>
+          </a:xfrm>
+          <a:prstGeom prst="rect">
+            <a:avLst/>
+          </a:prstGeom>
+          <a:solidFill>
+            <a:srgbClr val="1E293B"/>
+          </a:solidFill>
+          <a:ln>
+            <a:noFill/>
+          </a:ln>
+        </p:spPr>
+        <p:style>
+          <a:lnRef idx="1">
+            <a:schemeClr val="accent1"/>
+          </a:lnRef>
+          <a:fillRef idx="3">
+            <a:schemeClr val="accent1"/>
+          </a:fillRef>
+          <a:effectRef idx="2">
+            <a:schemeClr val="accent1"/>
+          </a:effectRef>
+          <a:fontRef idx="minor">
+            <a:schemeClr val="lt1"/>
+          </a:fontRef>
+        </p:style>
+        <p:txBody>
+          <a:bodyPr rtlCol="0" anchor="ctr"/>
+          <a:lstStyle/>
+          <a:p>
+            <a:pPr algn="ctr"/>
+            <a:endParaRPr/>
+          </a:p>
+        </p:txBody>
+      </p:sp>
+      <p:sp>
+        <p:nvSpPr>
+          <p:cNvPr id="5" name="TextBox 4"/>
+          <p:cNvSpPr txBox="1"/>
+          <p:nvPr/>
+        </p:nvSpPr>
+        <p:spPr>
+          <a:xfrm>
+            <a:off x="640080" y="5394960"/>
+            <a:ext cx="10881360" cy="914400"/>
+          </a:xfrm>
+          <a:prstGeom prst="rect">
+            <a:avLst/>
+          </a:prstGeom>
+          <a:noFill/>
+        </p:spPr>
+        <p:txBody>
+          <a:bodyPr wrap="square">
+            <a:spAutoFit/>
+          </a:bodyPr>
+          <a:lstStyle/>
+          <a:p>
+            <a:pPr>
+              <a:defRPr sz="1600" i="1">
+                <a:solidFill>
+                  <a:srgbClr val="94A3B8"/>
+                </a:solidFill>
+                <a:latin typeface="Times New Roman"/>
+              </a:defRPr>
+            </a:pPr>
+            <a:r>
+              <a:t>Аналогия: архитектор вносит правки в макет, сравнивает старый и новый, и только потом меняет реальное здание.</a:t>
             </a:r>
           </a:p>
         </p:txBody>
@@ -4009,13 +4922,13 @@
 </p:sld>
 </file>
 
-<file path=ppt/slides/slide6.xml><?xml version="1.0" encoding="utf-8"?>
-<p:sld xmlns:a="http://schemas.openxmlformats.org/drawingml/2006/main" xmlns:p="http://schemas.openxmlformats.org/presentationml/2006/main" xmlns:r="http://schemas.openxmlformats.org/officeDocument/2006/relationships">
+<file path=ppt/slides/slide4.xml><?xml version="1.0" encoding="utf-8"?>
+<p:sld xmlns:a="http://schemas.openxmlformats.org/drawingml/2006/main" xmlns:r="http://schemas.openxmlformats.org/officeDocument/2006/relationships" xmlns:p="http://schemas.openxmlformats.org/presentationml/2006/main">
   <p:cSld>
     <p:bg>
       <p:bgPr>
         <a:solidFill>
-          <a:srgbClr val="FFFFFF"/>
+          <a:srgbClr val="0F172A"/>
         </a:solidFill>
         <a:effectLst/>
       </p:bgPr>
@@ -4026,144 +4939,179 @@
         <p:cNvGrpSpPr/>
         <p:nvPr/>
       </p:nvGrpSpPr>
-      <p:grpSpPr/>
-      <p:sp>
-        <p:nvSpPr>
-          <p:cNvPr id="2" name="Title 1"/>
-          <p:cNvSpPr>
-            <a:spLocks noGrp="1"/>
-          </p:cNvSpPr>
-          <p:nvPr>
-            <p:ph type="title"/>
-          </p:nvPr>
-        </p:nvSpPr>
-        <p:spPr/>
-        <p:txBody>
-          <a:bodyPr wrap="square"/>
-          <a:lstStyle/>
-          <a:p>
-            <a:pPr>
-              <a:defRPr sz="3600" b="1">
-                <a:solidFill>
-                  <a:srgbClr val="1A1A1A"/>
-                </a:solidFill>
-                <a:latin typeface="Arial"/>
-              </a:defRPr>
-            </a:pPr>
-            <a:r>
-              <a:t>useState — внутренняя память</a:t>
-            </a:r>
-          </a:p>
-        </p:txBody>
-      </p:sp>
-      <p:sp>
-        <p:nvSpPr>
-          <p:cNvPr id="3" name="Content Placeholder 2"/>
-          <p:cNvSpPr>
-            <a:spLocks noGrp="1"/>
-          </p:cNvSpPr>
-          <p:nvPr>
-            <p:ph idx="1"/>
-          </p:nvPr>
-        </p:nvSpPr>
-        <p:spPr/>
-        <p:txBody>
-          <a:bodyPr wrap="square"/>
+      <p:grpSpPr>
+        <a:xfrm>
+          <a:off x="0" y="0"/>
+          <a:ext cx="0" cy="0"/>
+          <a:chOff x="0" y="0"/>
+          <a:chExt cx="0" cy="0"/>
+        </a:xfrm>
+      </p:grpSpPr>
+      <p:sp>
+        <p:nvSpPr>
+          <p:cNvPr id="2" name="TextBox 1"/>
+          <p:cNvSpPr txBox="1"/>
+          <p:nvPr/>
+        </p:nvSpPr>
+        <p:spPr>
+          <a:xfrm>
+            <a:off x="457200" y="365760"/>
+            <a:ext cx="11247120" cy="731520"/>
+          </a:xfrm>
+          <a:prstGeom prst="rect">
+            <a:avLst/>
+          </a:prstGeom>
+          <a:noFill/>
+        </p:spPr>
+        <p:txBody>
+          <a:bodyPr wrap="none">
+            <a:spAutoFit/>
+          </a:bodyPr>
+          <a:lstStyle/>
+          <a:p>
+            <a:pPr algn="l">
+              <a:defRPr sz="3200" b="1">
+                <a:solidFill>
+                  <a:srgbClr val="38BDF8"/>
+                </a:solidFill>
+                <a:latin typeface="Times New Roman"/>
+              </a:defRPr>
+            </a:pPr>
+            <a:r>
+              <a:t>2. Структура проекта</a:t>
+            </a:r>
+          </a:p>
+        </p:txBody>
+      </p:sp>
+      <p:sp>
+        <p:nvSpPr>
+          <p:cNvPr id="3" name="TextBox 2"/>
+          <p:cNvSpPr txBox="1"/>
+          <p:nvPr/>
+        </p:nvSpPr>
+        <p:spPr>
+          <a:xfrm>
+            <a:off x="457200" y="1097280"/>
+            <a:ext cx="11247120" cy="5303520"/>
+          </a:xfrm>
+          <a:prstGeom prst="rect">
+            <a:avLst/>
+          </a:prstGeom>
+          <a:noFill/>
+        </p:spPr>
+        <p:txBody>
+          <a:bodyPr wrap="square">
+            <a:spAutoFit/>
+          </a:bodyPr>
           <a:lstStyle/>
           <a:p>
             <a:pPr>
               <a:spcAft>
-                <a:spcPts val="1200"/>
+                <a:spcPts val="800"/>
               </a:spcAft>
-              <a:defRPr sz="2200">
-                <a:solidFill>
-                  <a:srgbClr val="333333"/>
-                </a:solidFill>
-                <a:latin typeface="Arial"/>
-              </a:defRPr>
-            </a:pPr>
-            <a:r>
-              <a:t>Хранит то, что меняется: счётчик, текст, флаг.</a:t>
+              <a:defRPr sz="2000">
+                <a:solidFill>
+                  <a:srgbClr val="FFFFFF"/>
+                </a:solidFill>
+                <a:latin typeface="Times New Roman"/>
+              </a:defRPr>
+            </a:pPr>
+            <a:r>
+              <a:t>CRA — инструмент от Meta на Webpack. Vite — современная альтернатива на ES-модулях и Rollup.</a:t>
             </a:r>
           </a:p>
           <a:p>
             <a:pPr>
               <a:spcAft>
-                <a:spcPts val="1200"/>
+                <a:spcPts val="800"/>
               </a:spcAft>
-              <a:defRPr sz="2200">
-                <a:solidFill>
-                  <a:srgbClr val="333333"/>
-                </a:solidFill>
-                <a:latin typeface="Arial"/>
-              </a:defRPr>
-            </a:pPr>
-            <a:r>
-              <a:t>Состояние = внутреннее. Пропсы = внешнее.</a:t>
+              <a:defRPr sz="2000">
+                <a:solidFill>
+                  <a:srgbClr val="FFFFFF"/>
+                </a:solidFill>
+                <a:latin typeface="Times New Roman"/>
+              </a:defRPr>
+            </a:pPr>
+            <a:r>
+              <a:t>Точка входа — index.jsx/main.jsx: импорт ReactDOM, createRoot(), рендер App.</a:t>
             </a:r>
           </a:p>
           <a:p>
             <a:pPr>
               <a:spcAft>
-                <a:spcPts val="1200"/>
+                <a:spcPts val="800"/>
               </a:spcAft>
-              <a:defRPr sz="2200">
-                <a:solidFill>
-                  <a:srgbClr val="333333"/>
-                </a:solidFill>
-                <a:latin typeface="Arial"/>
-              </a:defRPr>
-            </a:pPr>
-            <a:r>
-              <a:t>setState не мгновенный — React собирает изменения.</a:t>
+              <a:defRPr sz="2000">
+                <a:solidFill>
+                  <a:srgbClr val="FFFFFF"/>
+                </a:solidFill>
+                <a:latin typeface="Times New Roman"/>
+              </a:defRPr>
+            </a:pPr>
+            <a:r>
+              <a:t>div#root — контейнер в index.html, куда React монтирует всё приложение.</a:t>
             </a:r>
           </a:p>
           <a:p>
             <a:pPr>
               <a:spcAft>
-                <a:spcPts val="1200"/>
+                <a:spcPts val="800"/>
               </a:spcAft>
-              <a:defRPr sz="2200">
-                <a:solidFill>
-                  <a:srgbClr val="333333"/>
-                </a:solidFill>
-                <a:latin typeface="Arial"/>
-              </a:defRPr>
-            </a:pPr>
-            <a:r>
-              <a:t>Зависишь от прошлого значения? Пиши: setX(prev =&gt; prev + 1).</a:t>
-            </a:r>
+              <a:defRPr sz="2000">
+                <a:solidFill>
+                  <a:srgbClr val="FFFFFF"/>
+                </a:solidFill>
+                <a:latin typeface="Times New Roman"/>
+              </a:defRPr>
+            </a:pPr>
+            <a:endParaRPr/>
           </a:p>
           <a:p>
             <a:pPr>
               <a:spcAft>
-                <a:spcPts val="1200"/>
+                <a:spcPts val="800"/>
               </a:spcAft>
-              <a:defRPr sz="2200" b="1">
-                <a:solidFill>
-                  <a:srgbClr val="0066CC"/>
-                </a:solidFill>
-                <a:latin typeface="Arial"/>
-              </a:defRPr>
-            </a:pPr>
-            <a:r>
-              <a:t>[!] Не мутируй напрямую: arr.push() не сработает.</a:t>
+              <a:defRPr sz="2000">
+                <a:solidFill>
+                  <a:srgbClr val="FFFFFF"/>
+                </a:solidFill>
+                <a:latin typeface="Times New Roman"/>
+              </a:defRPr>
+            </a:pPr>
+            <a:r>
+              <a:t>Dev vs Production:</a:t>
             </a:r>
           </a:p>
           <a:p>
             <a:pPr>
               <a:spcAft>
-                <a:spcPts val="1200"/>
+                <a:spcPts val="800"/>
               </a:spcAft>
-              <a:defRPr sz="2200" b="1">
-                <a:solidFill>
-                  <a:srgbClr val="008844"/>
-                </a:solidFill>
-                <a:latin typeface="Arial"/>
-              </a:defRPr>
-            </a:pPr>
-            <a:r>
-              <a:t>[OK] Создавай новый массив/объект: [...arr], { ...obj }.</a:t>
+              <a:defRPr sz="2000">
+                <a:solidFill>
+                  <a:srgbClr val="FFFFFF"/>
+                </a:solidFill>
+                <a:latin typeface="Times New Roman"/>
+              </a:defRPr>
+            </a:pPr>
+            <a:r>
+              <a:t>  • Dev: карты исходного кода, подробные ошибки, горячая замена модулей</a:t>
+            </a:r>
+          </a:p>
+          <a:p>
+            <a:pPr>
+              <a:spcAft>
+                <a:spcPts val="800"/>
+              </a:spcAft>
+              <a:defRPr sz="2000">
+                <a:solidFill>
+                  <a:srgbClr val="FFFFFF"/>
+                </a:solidFill>
+                <a:latin typeface="Times New Roman"/>
+              </a:defRPr>
+            </a:pPr>
+            <a:r>
+              <a:t>  • Production: минификация, удаление неиспользуемого кода, разделение на чанки</a:t>
             </a:r>
           </a:p>
         </p:txBody>
@@ -4176,13 +5124,13 @@
 </p:sld>
 </file>
 
-<file path=ppt/slides/slide7.xml><?xml version="1.0" encoding="utf-8"?>
-<p:sld xmlns:a="http://schemas.openxmlformats.org/drawingml/2006/main" xmlns:p="http://schemas.openxmlformats.org/presentationml/2006/main" xmlns:r="http://schemas.openxmlformats.org/officeDocument/2006/relationships">
+<file path=ppt/slides/slide5.xml><?xml version="1.0" encoding="utf-8"?>
+<p:sld xmlns:a="http://schemas.openxmlformats.org/drawingml/2006/main" xmlns:r="http://schemas.openxmlformats.org/officeDocument/2006/relationships" xmlns:p="http://schemas.openxmlformats.org/presentationml/2006/main">
   <p:cSld>
     <p:bg>
       <p:bgPr>
         <a:solidFill>
-          <a:srgbClr val="FFFFFF"/>
+          <a:srgbClr val="0F172A"/>
         </a:solidFill>
         <a:effectLst/>
       </p:bgPr>
@@ -4193,160 +5141,281 @@
         <p:cNvGrpSpPr/>
         <p:nvPr/>
       </p:nvGrpSpPr>
-      <p:grpSpPr/>
-      <p:sp>
-        <p:nvSpPr>
-          <p:cNvPr id="2" name="Title 1"/>
-          <p:cNvSpPr>
-            <a:spLocks noGrp="1"/>
-          </p:cNvSpPr>
-          <p:nvPr>
-            <p:ph type="title"/>
-          </p:nvPr>
-        </p:nvSpPr>
-        <p:spPr/>
-        <p:txBody>
-          <a:bodyPr wrap="square"/>
-          <a:lstStyle/>
-          <a:p>
-            <a:pPr>
-              <a:defRPr sz="3600" b="1">
-                <a:solidFill>
-                  <a:srgbClr val="1A1A1A"/>
-                </a:solidFill>
-                <a:latin typeface="Arial"/>
-              </a:defRPr>
-            </a:pPr>
-            <a:r>
-              <a:t>useEffect — всё, кроме рисования</a:t>
-            </a:r>
-          </a:p>
-        </p:txBody>
-      </p:sp>
-      <p:sp>
-        <p:nvSpPr>
-          <p:cNvPr id="3" name="Content Placeholder 2"/>
-          <p:cNvSpPr>
-            <a:spLocks noGrp="1"/>
-          </p:cNvSpPr>
-          <p:nvPr>
-            <p:ph idx="1"/>
-          </p:nvPr>
-        </p:nvSpPr>
-        <p:spPr/>
-        <p:txBody>
-          <a:bodyPr wrap="square"/>
+      <p:grpSpPr>
+        <a:xfrm>
+          <a:off x="0" y="0"/>
+          <a:ext cx="0" cy="0"/>
+          <a:chOff x="0" y="0"/>
+          <a:chExt cx="0" cy="0"/>
+        </a:xfrm>
+      </p:grpSpPr>
+      <p:sp>
+        <p:nvSpPr>
+          <p:cNvPr id="2" name="TextBox 1"/>
+          <p:cNvSpPr txBox="1"/>
+          <p:nvPr/>
+        </p:nvSpPr>
+        <p:spPr>
+          <a:xfrm>
+            <a:off x="457200" y="365760"/>
+            <a:ext cx="11247120" cy="731520"/>
+          </a:xfrm>
+          <a:prstGeom prst="rect">
+            <a:avLst/>
+          </a:prstGeom>
+          <a:noFill/>
+        </p:spPr>
+        <p:txBody>
+          <a:bodyPr wrap="none">
+            <a:spAutoFit/>
+          </a:bodyPr>
+          <a:lstStyle/>
+          <a:p>
+            <a:pPr algn="l">
+              <a:defRPr sz="3200" b="1">
+                <a:solidFill>
+                  <a:srgbClr val="38BDF8"/>
+                </a:solidFill>
+                <a:latin typeface="Times New Roman"/>
+              </a:defRPr>
+            </a:pPr>
+            <a:r>
+              <a:t>3. JSX и React.createElement</a:t>
+            </a:r>
+          </a:p>
+        </p:txBody>
+      </p:sp>
+      <p:sp>
+        <p:nvSpPr>
+          <p:cNvPr id="3" name="TextBox 2"/>
+          <p:cNvSpPr txBox="1"/>
+          <p:nvPr/>
+        </p:nvSpPr>
+        <p:spPr>
+          <a:xfrm>
+            <a:off x="457200" y="1097280"/>
+            <a:ext cx="11247120" cy="5303520"/>
+          </a:xfrm>
+          <a:prstGeom prst="rect">
+            <a:avLst/>
+          </a:prstGeom>
+          <a:noFill/>
+        </p:spPr>
+        <p:txBody>
+          <a:bodyPr wrap="square">
+            <a:spAutoFit/>
+          </a:bodyPr>
           <a:lstStyle/>
           <a:p>
             <a:pPr>
               <a:spcAft>
-                <a:spcPts val="1200"/>
+                <a:spcPts val="800"/>
               </a:spcAft>
-              <a:defRPr sz="2200">
-                <a:solidFill>
-                  <a:srgbClr val="333333"/>
-                </a:solidFill>
-                <a:latin typeface="Arial"/>
-              </a:defRPr>
-            </a:pPr>
-            <a:r>
-              <a:t>Загрузка данных, таймеры, подписки, работа с DOM.</a:t>
+              <a:defRPr sz="2000">
+                <a:solidFill>
+                  <a:srgbClr val="FFFFFF"/>
+                </a:solidFill>
+                <a:latin typeface="Times New Roman"/>
+              </a:defRPr>
+            </a:pPr>
+            <a:r>
+              <a:t>JSX — синтаксическое расширение JS, транспилируется в React.createElement().</a:t>
             </a:r>
           </a:p>
           <a:p>
             <a:pPr>
               <a:spcAft>
-                <a:spcPts val="1200"/>
+                <a:spcPts val="800"/>
               </a:spcAft>
-              <a:defRPr sz="2200">
-                <a:solidFill>
-                  <a:srgbClr val="333333"/>
-                </a:solidFill>
-                <a:latin typeface="Arial"/>
-              </a:defRPr>
-            </a:pPr>
-            <a:r>
-              <a:t>Массив зависимостей говорит, когда запускаться:</a:t>
-            </a:r>
-          </a:p>
-          <a:p>
-            <a:pPr lvl="1">
+              <a:defRPr sz="2000">
+                <a:solidFill>
+                  <a:srgbClr val="FFFFFF"/>
+                </a:solidFill>
+                <a:latin typeface="Times New Roman"/>
+              </a:defRPr>
+            </a:pPr>
+            <a:endParaRPr/>
+          </a:p>
+          <a:p>
+            <a:pPr>
               <a:spcAft>
-                <a:spcPts val="1200"/>
+                <a:spcPts val="800"/>
               </a:spcAft>
-              <a:defRPr sz="2200">
-                <a:solidFill>
-                  <a:srgbClr val="333333"/>
-                </a:solidFill>
-                <a:latin typeface="Arial"/>
-              </a:defRPr>
-            </a:pPr>
-            <a:r>
-              <a:t>  → нет массива — после каждой перерисовки.</a:t>
-            </a:r>
-          </a:p>
-          <a:p>
-            <a:pPr lvl="1">
+              <a:defRPr sz="2000">
+                <a:solidFill>
+                  <a:srgbClr val="FFFFFF"/>
+                </a:solidFill>
+                <a:latin typeface="Times New Roman"/>
+              </a:defRPr>
+            </a:pPr>
+            <a:r>
+              <a:t>Правила JSX:</a:t>
+            </a:r>
+          </a:p>
+          <a:p>
+            <a:pPr>
               <a:spcAft>
-                <a:spcPts val="1200"/>
+                <a:spcPts val="800"/>
               </a:spcAft>
-              <a:defRPr sz="2200">
-                <a:solidFill>
-                  <a:srgbClr val="333333"/>
-                </a:solidFill>
-                <a:latin typeface="Arial"/>
-              </a:defRPr>
-            </a:pPr>
-            <a:r>
-              <a:t>  → [] — один раз при появлении на экране.</a:t>
-            </a:r>
-          </a:p>
-          <a:p>
-            <a:pPr lvl="1">
+              <a:defRPr sz="2000">
+                <a:solidFill>
+                  <a:srgbClr val="FFFFFF"/>
+                </a:solidFill>
+                <a:latin typeface="Times New Roman"/>
+              </a:defRPr>
+            </a:pPr>
+            <a:r>
+              <a:t>  • Один корневой элемент</a:t>
+            </a:r>
+          </a:p>
+          <a:p>
+            <a:pPr>
               <a:spcAft>
-                <a:spcPts val="1200"/>
+                <a:spcPts val="800"/>
               </a:spcAft>
-              <a:defRPr sz="2200">
-                <a:solidFill>
-                  <a:srgbClr val="333333"/>
-                </a:solidFill>
-                <a:latin typeface="Arial"/>
-              </a:defRPr>
-            </a:pPr>
-            <a:r>
-              <a:t>  → [x] — когда x изменился.</a:t>
+              <a:defRPr sz="2000">
+                <a:solidFill>
+                  <a:srgbClr val="FFFFFF"/>
+                </a:solidFill>
+                <a:latin typeface="Times New Roman"/>
+              </a:defRPr>
+            </a:pPr>
+            <a:r>
+              <a:t>  • camelCase атрибуты: className, onClick, htmlFor</a:t>
             </a:r>
           </a:p>
           <a:p>
             <a:pPr>
               <a:spcAft>
-                <a:spcPts val="1200"/>
+                <a:spcPts val="800"/>
               </a:spcAft>
-              <a:defRPr sz="2200">
-                <a:solidFill>
-                  <a:srgbClr val="333333"/>
-                </a:solidFill>
-                <a:latin typeface="Arial"/>
-              </a:defRPr>
-            </a:pPr>
-            <a:r>
-              <a:t>Cleanup: убираем за собой (отмена запроса, таймер).</a:t>
+              <a:defRPr sz="2000">
+                <a:solidFill>
+                  <a:srgbClr val="FFFFFF"/>
+                </a:solidFill>
+                <a:latin typeface="Times New Roman"/>
+              </a:defRPr>
+            </a:pPr>
+            <a:r>
+              <a:t>  • Все теги закрыты: &lt;img /&gt;, &lt;br /&gt;</a:t>
             </a:r>
           </a:p>
           <a:p>
             <a:pPr>
               <a:spcAft>
-                <a:spcPts val="1200"/>
+                <a:spcPts val="800"/>
               </a:spcAft>
-              <a:defRPr sz="2200" b="1">
-                <a:solidFill>
-                  <a:srgbClr val="0066CC"/>
-                </a:solidFill>
-                <a:latin typeface="Arial"/>
-              </a:defRPr>
-            </a:pPr>
-            <a:r>
-              <a:t>[!] Не обновляй внутри то, что указал в зависимостях — петля!</a:t>
+              <a:defRPr sz="2000">
+                <a:solidFill>
+                  <a:srgbClr val="FFFFFF"/>
+                </a:solidFill>
+                <a:latin typeface="Times New Roman"/>
+              </a:defRPr>
+            </a:pPr>
+            <a:endParaRPr/>
+          </a:p>
+          <a:p>
+            <a:pPr>
+              <a:spcAft>
+                <a:spcPts val="800"/>
+              </a:spcAft>
+              <a:defRPr sz="2000">
+                <a:solidFill>
+                  <a:srgbClr val="FFFFFF"/>
+                </a:solidFill>
+                <a:latin typeface="Times New Roman"/>
+              </a:defRPr>
+            </a:pPr>
+            <a:r>
+              <a:t>Проблема без фрагмента: функция не может вернуть несколько элементов. Решение — &lt;&gt;...&lt;/&gt; (React.Fragment).</a:t>
+            </a:r>
+          </a:p>
+        </p:txBody>
+      </p:sp>
+      <p:sp>
+        <p:nvSpPr>
+          <p:cNvPr id="4" name="Rectangle 3"/>
+          <p:cNvSpPr/>
+          <p:nvPr/>
+        </p:nvSpPr>
+        <p:spPr>
+          <a:xfrm>
+            <a:off x="457200" y="4572000"/>
+            <a:ext cx="11247120" cy="1828800"/>
+          </a:xfrm>
+          <a:prstGeom prst="rect">
+            <a:avLst/>
+          </a:prstGeom>
+          <a:solidFill>
+            <a:srgbClr val="020617"/>
+          </a:solidFill>
+          <a:ln>
+            <a:noFill/>
+          </a:ln>
+        </p:spPr>
+        <p:style>
+          <a:lnRef idx="1">
+            <a:schemeClr val="accent1"/>
+          </a:lnRef>
+          <a:fillRef idx="3">
+            <a:schemeClr val="accent1"/>
+          </a:fillRef>
+          <a:effectRef idx="2">
+            <a:schemeClr val="accent1"/>
+          </a:effectRef>
+          <a:fontRef idx="minor">
+            <a:schemeClr val="lt1"/>
+          </a:fontRef>
+        </p:style>
+        <p:txBody>
+          <a:bodyPr rtlCol="0" anchor="ctr"/>
+          <a:lstStyle/>
+          <a:p>
+            <a:pPr algn="ctr"/>
+            <a:endParaRPr/>
+          </a:p>
+        </p:txBody>
+      </p:sp>
+      <p:sp>
+        <p:nvSpPr>
+          <p:cNvPr id="5" name="TextBox 4"/>
+          <p:cNvSpPr txBox="1"/>
+          <p:nvPr/>
+        </p:nvSpPr>
+        <p:spPr>
+          <a:xfrm>
+            <a:off x="640080" y="4663440"/>
+            <a:ext cx="10881360" cy="1645920"/>
+          </a:xfrm>
+          <a:prstGeom prst="rect">
+            <a:avLst/>
+          </a:prstGeom>
+          <a:noFill/>
+        </p:spPr>
+        <p:txBody>
+          <a:bodyPr wrap="square">
+            <a:spAutoFit/>
+          </a:bodyPr>
+          <a:lstStyle/>
+          <a:p>
+            <a:pPr>
+              <a:defRPr sz="1400">
+                <a:solidFill>
+                  <a:srgbClr val="34D399"/>
+                </a:solidFill>
+                <a:latin typeface="Consolas"/>
+              </a:defRPr>
+            </a:pPr>
+            <a:r>
+              <a:t>&lt;div className="app"&gt;Hello&lt;/div&gt;</a:t>
+            </a:r>
+            <a:br/>
+            <a:r>
+              <a:t>// транспилируется в:</a:t>
+            </a:r>
+            <a:br/>
+            <a:r>
+              <a:t>React.createElement("div", { className: "app" }, "Hello")</a:t>
             </a:r>
           </a:p>
         </p:txBody>
@@ -4359,13 +5428,13 @@
 </p:sld>
 </file>
 
-<file path=ppt/slides/slide8.xml><?xml version="1.0" encoding="utf-8"?>
-<p:sld xmlns:a="http://schemas.openxmlformats.org/drawingml/2006/main" xmlns:p="http://schemas.openxmlformats.org/presentationml/2006/main" xmlns:r="http://schemas.openxmlformats.org/officeDocument/2006/relationships">
+<file path=ppt/slides/slide6.xml><?xml version="1.0" encoding="utf-8"?>
+<p:sld xmlns:a="http://schemas.openxmlformats.org/drawingml/2006/main" xmlns:r="http://schemas.openxmlformats.org/officeDocument/2006/relationships" xmlns:p="http://schemas.openxmlformats.org/presentationml/2006/main">
   <p:cSld>
     <p:bg>
       <p:bgPr>
         <a:solidFill>
-          <a:srgbClr val="FFFFFF"/>
+          <a:srgbClr val="0F172A"/>
         </a:solidFill>
         <a:effectLst/>
       </p:bgPr>
@@ -4376,128 +5445,518 @@
         <p:cNvGrpSpPr/>
         <p:nvPr/>
       </p:nvGrpSpPr>
-      <p:grpSpPr/>
-      <p:sp>
-        <p:nvSpPr>
-          <p:cNvPr id="2" name="Title 1"/>
-          <p:cNvSpPr>
-            <a:spLocks noGrp="1"/>
-          </p:cNvSpPr>
-          <p:nvPr>
-            <p:ph type="title"/>
-          </p:nvPr>
-        </p:nvSpPr>
-        <p:spPr/>
-        <p:txBody>
-          <a:bodyPr wrap="square"/>
-          <a:lstStyle/>
-          <a:p>
-            <a:pPr>
-              <a:defRPr sz="3600" b="1">
-                <a:solidFill>
-                  <a:srgbClr val="1A1A1A"/>
-                </a:solidFill>
-                <a:latin typeface="Arial"/>
-              </a:defRPr>
-            </a:pPr>
-            <a:r>
-              <a:t>Роутинг — переходы без перезагрузки</a:t>
-            </a:r>
-          </a:p>
-        </p:txBody>
-      </p:sp>
-      <p:sp>
-        <p:nvSpPr>
-          <p:cNvPr id="3" name="Content Placeholder 2"/>
-          <p:cNvSpPr>
-            <a:spLocks noGrp="1"/>
-          </p:cNvSpPr>
-          <p:nvPr>
-            <p:ph idx="1"/>
-          </p:nvPr>
-        </p:nvSpPr>
-        <p:spPr/>
-        <p:txBody>
-          <a:bodyPr wrap="square"/>
+      <p:grpSpPr>
+        <a:xfrm>
+          <a:off x="0" y="0"/>
+          <a:ext cx="0" cy="0"/>
+          <a:chOff x="0" y="0"/>
+          <a:chExt cx="0" cy="0"/>
+        </a:xfrm>
+      </p:grpSpPr>
+      <p:sp>
+        <p:nvSpPr>
+          <p:cNvPr id="2" name="TextBox 1"/>
+          <p:cNvSpPr txBox="1"/>
+          <p:nvPr/>
+        </p:nvSpPr>
+        <p:spPr>
+          <a:xfrm>
+            <a:off x="457200" y="365760"/>
+            <a:ext cx="11247120" cy="731520"/>
+          </a:xfrm>
+          <a:prstGeom prst="rect">
+            <a:avLst/>
+          </a:prstGeom>
+          <a:noFill/>
+        </p:spPr>
+        <p:txBody>
+          <a:bodyPr wrap="none">
+            <a:spAutoFit/>
+          </a:bodyPr>
+          <a:lstStyle/>
+          <a:p>
+            <a:pPr algn="l">
+              <a:defRPr sz="3200" b="1">
+                <a:solidFill>
+                  <a:srgbClr val="38BDF8"/>
+                </a:solidFill>
+                <a:latin typeface="Times New Roman"/>
+              </a:defRPr>
+            </a:pPr>
+            <a:r>
+              <a:t>4. Компоненты</a:t>
+            </a:r>
+          </a:p>
+        </p:txBody>
+      </p:sp>
+      <p:sp>
+        <p:nvSpPr>
+          <p:cNvPr id="3" name="TextBox 2"/>
+          <p:cNvSpPr txBox="1"/>
+          <p:nvPr/>
+        </p:nvSpPr>
+        <p:spPr>
+          <a:xfrm>
+            <a:off x="457200" y="1097280"/>
+            <a:ext cx="11247120" cy="5303520"/>
+          </a:xfrm>
+          <a:prstGeom prst="rect">
+            <a:avLst/>
+          </a:prstGeom>
+          <a:noFill/>
+        </p:spPr>
+        <p:txBody>
+          <a:bodyPr wrap="square">
+            <a:spAutoFit/>
+          </a:bodyPr>
           <a:lstStyle/>
           <a:p>
             <a:pPr>
               <a:spcAft>
-                <a:spcPts val="1200"/>
+                <a:spcPts val="800"/>
               </a:spcAft>
-              <a:defRPr sz="2200">
-                <a:solidFill>
-                  <a:srgbClr val="333333"/>
-                </a:solidFill>
-                <a:latin typeface="Arial"/>
-              </a:defRPr>
-            </a:pPr>
-            <a:r>
-              <a:t>SPA: страницы меняются мгновенно, как в приложении.</a:t>
+              <a:defRPr sz="1800">
+                <a:solidFill>
+                  <a:srgbClr val="FFFFFF"/>
+                </a:solidFill>
+                <a:latin typeface="Times New Roman"/>
+              </a:defRPr>
+            </a:pPr>
+            <a:r>
+              <a:rPr dirty="0" err="1"/>
+              <a:t>Компонент</a:t>
+            </a:r>
+            <a:r>
+              <a:rPr dirty="0"/>
+              <a:t> — </a:t>
+            </a:r>
+            <a:r>
+              <a:rPr dirty="0" err="1"/>
+              <a:t>независимый</a:t>
+            </a:r>
+            <a:r>
+              <a:rPr dirty="0"/>
+              <a:t> </a:t>
+            </a:r>
+            <a:r>
+              <a:rPr dirty="0" err="1"/>
+              <a:t>блок</a:t>
+            </a:r>
+            <a:r>
+              <a:rPr dirty="0"/>
+              <a:t> </a:t>
+            </a:r>
+            <a:r>
+              <a:rPr dirty="0" err="1"/>
+              <a:t>интерфейса</a:t>
+            </a:r>
+            <a:r>
+              <a:rPr dirty="0"/>
+              <a:t>, </a:t>
+            </a:r>
+            <a:r>
+              <a:rPr dirty="0" err="1"/>
+              <a:t>принимающий</a:t>
+            </a:r>
+            <a:r>
+              <a:rPr dirty="0"/>
+              <a:t> </a:t>
+            </a:r>
+            <a:r>
+              <a:rPr dirty="0" err="1"/>
+              <a:t>пропсы</a:t>
+            </a:r>
+            <a:r>
+              <a:rPr dirty="0"/>
+              <a:t> и </a:t>
+            </a:r>
+            <a:r>
+              <a:rPr dirty="0" err="1"/>
+              <a:t>возвращающий</a:t>
+            </a:r>
+            <a:r>
+              <a:rPr dirty="0"/>
+              <a:t> JSX.</a:t>
             </a:r>
           </a:p>
           <a:p>
             <a:pPr>
               <a:spcAft>
-                <a:spcPts val="1200"/>
+                <a:spcPts val="800"/>
               </a:spcAft>
-              <a:defRPr sz="2200">
-                <a:solidFill>
-                  <a:srgbClr val="333333"/>
-                </a:solidFill>
-                <a:latin typeface="Arial"/>
-              </a:defRPr>
-            </a:pPr>
-            <a:r>
-              <a:t>BrowserRouter → Routes → Route.</a:t>
-            </a:r>
+              <a:defRPr sz="1800">
+                <a:solidFill>
+                  <a:srgbClr val="FFFFFF"/>
+                </a:solidFill>
+                <a:latin typeface="Times New Roman"/>
+              </a:defRPr>
+            </a:pPr>
+            <a:endParaRPr dirty="0"/>
           </a:p>
           <a:p>
             <a:pPr>
               <a:spcAft>
-                <a:spcPts val="1200"/>
+                <a:spcPts val="800"/>
               </a:spcAft>
-              <a:defRPr sz="2200">
-                <a:solidFill>
-                  <a:srgbClr val="333333"/>
-                </a:solidFill>
-                <a:latin typeface="Arial"/>
-              </a:defRPr>
-            </a:pPr>
-            <a:r>
-              <a:t>Link меняет адрес без перезагрузки.</a:t>
+              <a:defRPr sz="1800">
+                <a:solidFill>
+                  <a:srgbClr val="FFFFFF"/>
+                </a:solidFill>
+                <a:latin typeface="Times New Roman"/>
+              </a:defRPr>
+            </a:pPr>
+            <a:r>
+              <a:rPr dirty="0" err="1"/>
+              <a:t>Классовые</a:t>
+            </a:r>
+            <a:r>
+              <a:rPr dirty="0"/>
+              <a:t> (</a:t>
+            </a:r>
+            <a:r>
+              <a:rPr dirty="0" err="1"/>
+              <a:t>устаревшие</a:t>
+            </a:r>
+            <a:r>
+              <a:rPr dirty="0"/>
+              <a:t>): </a:t>
+            </a:r>
+            <a:r>
+              <a:rPr dirty="0" err="1"/>
+              <a:t>наследуют</a:t>
+            </a:r>
+            <a:r>
+              <a:rPr dirty="0"/>
+              <a:t> </a:t>
+            </a:r>
+            <a:r>
+              <a:rPr dirty="0" err="1"/>
+              <a:t>React.Component</a:t>
+            </a:r>
+            <a:r>
+              <a:rPr dirty="0"/>
+              <a:t>. </a:t>
+            </a:r>
+            <a:r>
+              <a:rPr dirty="0" err="1"/>
+              <a:t>Имеют</a:t>
+            </a:r>
+            <a:r>
+              <a:rPr dirty="0"/>
+              <a:t> render(), </a:t>
+            </a:r>
+            <a:r>
+              <a:rPr dirty="0" err="1"/>
+              <a:t>this.state</a:t>
+            </a:r>
+            <a:r>
+              <a:rPr dirty="0"/>
+              <a:t>, </a:t>
+            </a:r>
+            <a:r>
+              <a:rPr dirty="0" err="1"/>
+              <a:t>методы</a:t>
+            </a:r>
+            <a:r>
+              <a:rPr dirty="0"/>
+              <a:t> </a:t>
+            </a:r>
+            <a:r>
+              <a:rPr dirty="0" err="1"/>
+              <a:t>жизненного</a:t>
+            </a:r>
+            <a:r>
+              <a:rPr dirty="0"/>
+              <a:t> </a:t>
+            </a:r>
+            <a:r>
+              <a:rPr dirty="0" err="1"/>
+              <a:t>цикла</a:t>
+            </a:r>
+            <a:r>
+              <a:rPr dirty="0"/>
+              <a:t>.</a:t>
             </a:r>
           </a:p>
           <a:p>
             <a:pPr>
               <a:spcAft>
-                <a:spcPts val="1200"/>
+                <a:spcPts val="800"/>
               </a:spcAft>
-              <a:defRPr sz="2200" b="1">
-                <a:solidFill>
-                  <a:srgbClr val="0066CC"/>
-                </a:solidFill>
-                <a:latin typeface="Arial"/>
-              </a:defRPr>
-            </a:pPr>
-            <a:r>
-              <a:t>[!] Обычная &lt;a&gt; перезагружает страницу — убивает SPA!</a:t>
+              <a:defRPr sz="1800">
+                <a:solidFill>
+                  <a:srgbClr val="FFFFFF"/>
+                </a:solidFill>
+                <a:latin typeface="Times New Roman"/>
+              </a:defRPr>
+            </a:pPr>
+            <a:r>
+              <a:rPr dirty="0" err="1"/>
+              <a:t>Функциональные</a:t>
+            </a:r>
+            <a:r>
+              <a:rPr dirty="0"/>
+              <a:t> (</a:t>
+            </a:r>
+            <a:r>
+              <a:rPr dirty="0" err="1"/>
+              <a:t>современные</a:t>
+            </a:r>
+            <a:r>
+              <a:rPr dirty="0"/>
+              <a:t>): </a:t>
+            </a:r>
+            <a:r>
+              <a:rPr dirty="0" err="1"/>
+              <a:t>обычные</a:t>
+            </a:r>
+            <a:r>
+              <a:rPr dirty="0"/>
+              <a:t> </a:t>
+            </a:r>
+            <a:r>
+              <a:rPr dirty="0" err="1"/>
+              <a:t>функции</a:t>
+            </a:r>
+            <a:r>
+              <a:rPr dirty="0"/>
+              <a:t> JS + </a:t>
+            </a:r>
+            <a:r>
+              <a:rPr dirty="0" err="1"/>
+              <a:t>хуки</a:t>
+            </a:r>
+            <a:r>
+              <a:rPr dirty="0"/>
+              <a:t>. </a:t>
+            </a:r>
+            <a:r>
+              <a:rPr dirty="0" err="1"/>
+              <a:t>Стандарт</a:t>
+            </a:r>
+            <a:r>
+              <a:rPr dirty="0"/>
+              <a:t> с React 16.8.</a:t>
             </a:r>
           </a:p>
           <a:p>
             <a:pPr>
               <a:spcAft>
-                <a:spcPts val="1200"/>
+                <a:spcPts val="800"/>
               </a:spcAft>
-              <a:defRPr sz="2200">
-                <a:solidFill>
-                  <a:srgbClr val="333333"/>
-                </a:solidFill>
-                <a:latin typeface="Arial"/>
-              </a:defRPr>
-            </a:pPr>
-            <a:r>
-              <a:t>Динамические адреса: /product/123 → useParams() → 123.</a:t>
+              <a:defRPr sz="1800">
+                <a:solidFill>
+                  <a:srgbClr val="FFFFFF"/>
+                </a:solidFill>
+                <a:latin typeface="Times New Roman"/>
+              </a:defRPr>
+            </a:pPr>
+            <a:endParaRPr dirty="0"/>
+          </a:p>
+          <a:p>
+            <a:pPr>
+              <a:spcAft>
+                <a:spcPts val="800"/>
+              </a:spcAft>
+              <a:defRPr sz="1800">
+                <a:solidFill>
+                  <a:srgbClr val="FFFFFF"/>
+                </a:solidFill>
+                <a:latin typeface="Times New Roman"/>
+              </a:defRPr>
+            </a:pPr>
+            <a:r>
+              <a:rPr dirty="0"/>
+              <a:t>SRP — </a:t>
+            </a:r>
+            <a:r>
+              <a:rPr dirty="0" err="1"/>
+              <a:t>каждый</a:t>
+            </a:r>
+            <a:r>
+              <a:rPr dirty="0"/>
+              <a:t> </a:t>
+            </a:r>
+            <a:r>
+              <a:rPr dirty="0" err="1"/>
+              <a:t>компонент</a:t>
+            </a:r>
+            <a:r>
+              <a:rPr dirty="0"/>
+              <a:t> </a:t>
+            </a:r>
+            <a:r>
+              <a:rPr dirty="0" err="1"/>
+              <a:t>отвечает</a:t>
+            </a:r>
+            <a:r>
+              <a:rPr dirty="0"/>
+              <a:t> </a:t>
+            </a:r>
+            <a:r>
+              <a:rPr dirty="0" err="1"/>
+              <a:t>за</a:t>
+            </a:r>
+            <a:r>
+              <a:rPr dirty="0"/>
+              <a:t> </a:t>
+            </a:r>
+            <a:r>
+              <a:rPr dirty="0" err="1"/>
+              <a:t>одну</a:t>
+            </a:r>
+            <a:r>
+              <a:rPr dirty="0"/>
+              <a:t> </a:t>
+            </a:r>
+            <a:r>
+              <a:rPr dirty="0" err="1"/>
+              <a:t>задачу</a:t>
+            </a:r>
+            <a:r>
+              <a:rPr dirty="0"/>
+              <a:t>. </a:t>
+            </a:r>
+            <a:r>
+              <a:rPr dirty="0" err="1"/>
+              <a:t>Декомпозиция</a:t>
+            </a:r>
+            <a:r>
+              <a:rPr dirty="0"/>
+              <a:t> — </a:t>
+            </a:r>
+            <a:r>
+              <a:rPr dirty="0" err="1"/>
+              <a:t>разбиение</a:t>
+            </a:r>
+            <a:r>
+              <a:rPr dirty="0"/>
+              <a:t> </a:t>
+            </a:r>
+            <a:r>
+              <a:rPr dirty="0" err="1"/>
+              <a:t>монолита</a:t>
+            </a:r>
+            <a:r>
+              <a:rPr dirty="0"/>
+              <a:t> </a:t>
+            </a:r>
+            <a:r>
+              <a:rPr dirty="0" err="1"/>
+              <a:t>на</a:t>
+            </a:r>
+            <a:r>
+              <a:rPr dirty="0"/>
+              <a:t> </a:t>
+            </a:r>
+            <a:r>
+              <a:rPr dirty="0" err="1"/>
+              <a:t>мелкие</a:t>
+            </a:r>
+            <a:r>
+              <a:rPr dirty="0"/>
+              <a:t> </a:t>
+            </a:r>
+            <a:r>
+              <a:rPr dirty="0" err="1"/>
+              <a:t>компоненты</a:t>
+            </a:r>
+            <a:r>
+              <a:rPr dirty="0"/>
+              <a:t>.</a:t>
+            </a:r>
+          </a:p>
+        </p:txBody>
+      </p:sp>
+      <p:sp>
+        <p:nvSpPr>
+          <p:cNvPr id="4" name="Rectangle 3"/>
+          <p:cNvSpPr/>
+          <p:nvPr/>
+        </p:nvSpPr>
+        <p:spPr>
+          <a:xfrm>
+            <a:off x="457200" y="5303520"/>
+            <a:ext cx="91440" cy="914400"/>
+          </a:xfrm>
+          <a:prstGeom prst="rect">
+            <a:avLst/>
+          </a:prstGeom>
+          <a:solidFill>
+            <a:srgbClr val="F87171"/>
+          </a:solidFill>
+          <a:ln>
+            <a:noFill/>
+          </a:ln>
+        </p:spPr>
+        <p:style>
+          <a:lnRef idx="1">
+            <a:schemeClr val="accent1"/>
+          </a:lnRef>
+          <a:fillRef idx="3">
+            <a:schemeClr val="accent1"/>
+          </a:fillRef>
+          <a:effectRef idx="2">
+            <a:schemeClr val="accent1"/>
+          </a:effectRef>
+          <a:fontRef idx="minor">
+            <a:schemeClr val="lt1"/>
+          </a:fontRef>
+        </p:style>
+        <p:txBody>
+          <a:bodyPr rtlCol="0" anchor="ctr"/>
+          <a:lstStyle/>
+          <a:p>
+            <a:pPr algn="ctr"/>
+            <a:endParaRPr/>
+          </a:p>
+        </p:txBody>
+      </p:sp>
+      <p:sp>
+        <p:nvSpPr>
+          <p:cNvPr id="5" name="TextBox 4"/>
+          <p:cNvSpPr txBox="1"/>
+          <p:nvPr/>
+        </p:nvSpPr>
+        <p:spPr>
+          <a:xfrm>
+            <a:off x="640080" y="5303520"/>
+            <a:ext cx="10972800" cy="914400"/>
+          </a:xfrm>
+          <a:prstGeom prst="rect">
+            <a:avLst/>
+          </a:prstGeom>
+          <a:noFill/>
+        </p:spPr>
+        <p:txBody>
+          <a:bodyPr wrap="square">
+            <a:spAutoFit/>
+          </a:bodyPr>
+          <a:lstStyle/>
+          <a:p>
+            <a:pPr>
+              <a:defRPr sz="1800" b="1">
+                <a:solidFill>
+                  <a:srgbClr val="F87171"/>
+                </a:solidFill>
+                <a:latin typeface="Times New Roman"/>
+              </a:defRPr>
+            </a:pPr>
+            <a:r>
+              <a:t>Ошибка:</a:t>
+            </a:r>
+          </a:p>
+          <a:p>
+            <a:pPr>
+              <a:defRPr sz="1600">
+                <a:solidFill>
+                  <a:srgbClr val="FFFFFF"/>
+                </a:solidFill>
+                <a:latin typeface="Times New Roman"/>
+              </a:defRPr>
+            </a:pPr>
+            <a:r>
+              <a:t>Не объявляй компонент внутри другого — при каждом рендере создаётся новый тип, DOM пересоздаётся с нуля.</a:t>
             </a:r>
           </a:p>
         </p:txBody>
@@ -4510,13 +5969,13 @@
 </p:sld>
 </file>
 
-<file path=ppt/slides/slide9.xml><?xml version="1.0" encoding="utf-8"?>
-<p:sld xmlns:a="http://schemas.openxmlformats.org/drawingml/2006/main" xmlns:p="http://schemas.openxmlformats.org/presentationml/2006/main" xmlns:r="http://schemas.openxmlformats.org/officeDocument/2006/relationships">
+<file path=ppt/slides/slide7.xml><?xml version="1.0" encoding="utf-8"?>
+<p:sld xmlns:a="http://schemas.openxmlformats.org/drawingml/2006/main" xmlns:r="http://schemas.openxmlformats.org/officeDocument/2006/relationships" xmlns:p="http://schemas.openxmlformats.org/presentationml/2006/main">
   <p:cSld>
     <p:bg>
       <p:bgPr>
         <a:solidFill>
-          <a:srgbClr val="FFFFFF"/>
+          <a:srgbClr val="0F172A"/>
         </a:solidFill>
         <a:effectLst/>
       </p:bgPr>
@@ -4527,144 +5986,907 @@
         <p:cNvGrpSpPr/>
         <p:nvPr/>
       </p:nvGrpSpPr>
-      <p:grpSpPr/>
-      <p:sp>
-        <p:nvSpPr>
-          <p:cNvPr id="2" name="Title 1"/>
-          <p:cNvSpPr>
-            <a:spLocks noGrp="1"/>
-          </p:cNvSpPr>
-          <p:nvPr>
-            <p:ph type="title"/>
-          </p:nvPr>
-        </p:nvSpPr>
-        <p:spPr/>
-        <p:txBody>
-          <a:bodyPr wrap="square"/>
-          <a:lstStyle/>
-          <a:p>
-            <a:pPr>
-              <a:defRPr sz="3600" b="1">
-                <a:solidFill>
-                  <a:srgbClr val="1A1A1A"/>
-                </a:solidFill>
-                <a:latin typeface="Arial"/>
-              </a:defRPr>
-            </a:pPr>
-            <a:r>
-              <a:t>Запросы к серверу</a:t>
-            </a:r>
-          </a:p>
-        </p:txBody>
-      </p:sp>
-      <p:sp>
-        <p:nvSpPr>
-          <p:cNvPr id="3" name="Content Placeholder 2"/>
-          <p:cNvSpPr>
-            <a:spLocks noGrp="1"/>
-          </p:cNvSpPr>
-          <p:nvPr>
-            <p:ph idx="1"/>
-          </p:nvPr>
-        </p:nvSpPr>
-        <p:spPr/>
-        <p:txBody>
-          <a:bodyPr wrap="square"/>
+      <p:grpSpPr>
+        <a:xfrm>
+          <a:off x="0" y="0"/>
+          <a:ext cx="0" cy="0"/>
+          <a:chOff x="0" y="0"/>
+          <a:chExt cx="0" cy="0"/>
+        </a:xfrm>
+      </p:grpSpPr>
+      <p:sp>
+        <p:nvSpPr>
+          <p:cNvPr id="2" name="TextBox 1"/>
+          <p:cNvSpPr txBox="1"/>
+          <p:nvPr/>
+        </p:nvSpPr>
+        <p:spPr>
+          <a:xfrm>
+            <a:off x="457200" y="365760"/>
+            <a:ext cx="11247120" cy="731520"/>
+          </a:xfrm>
+          <a:prstGeom prst="rect">
+            <a:avLst/>
+          </a:prstGeom>
+          <a:noFill/>
+        </p:spPr>
+        <p:txBody>
+          <a:bodyPr wrap="none">
+            <a:spAutoFit/>
+          </a:bodyPr>
+          <a:lstStyle/>
+          <a:p>
+            <a:pPr algn="l">
+              <a:defRPr sz="3200" b="1">
+                <a:solidFill>
+                  <a:srgbClr val="38BDF8"/>
+                </a:solidFill>
+                <a:latin typeface="Times New Roman"/>
+              </a:defRPr>
+            </a:pPr>
+            <a:r>
+              <a:t>5. Поток данных и пропсы</a:t>
+            </a:r>
+          </a:p>
+        </p:txBody>
+      </p:sp>
+      <p:sp>
+        <p:nvSpPr>
+          <p:cNvPr id="3" name="TextBox 2"/>
+          <p:cNvSpPr txBox="1"/>
+          <p:nvPr/>
+        </p:nvSpPr>
+        <p:spPr>
+          <a:xfrm>
+            <a:off x="457200" y="1097280"/>
+            <a:ext cx="11247120" cy="5303520"/>
+          </a:xfrm>
+          <a:prstGeom prst="rect">
+            <a:avLst/>
+          </a:prstGeom>
+          <a:noFill/>
+        </p:spPr>
+        <p:txBody>
+          <a:bodyPr wrap="square">
+            <a:spAutoFit/>
+          </a:bodyPr>
           <a:lstStyle/>
           <a:p>
             <a:pPr>
               <a:spcAft>
-                <a:spcPts val="1200"/>
+                <a:spcPts val="800"/>
               </a:spcAft>
-              <a:defRPr sz="2200">
-                <a:solidFill>
-                  <a:srgbClr val="333333"/>
-                </a:solidFill>
-                <a:latin typeface="Arial"/>
-              </a:defRPr>
-            </a:pPr>
-            <a:r>
-              <a:t>Загружаем в useEffect с [] при открытии страницы.</a:t>
+              <a:defRPr sz="2000">
+                <a:solidFill>
+                  <a:srgbClr val="FFFFFF"/>
+                </a:solidFill>
+                <a:latin typeface="Times New Roman"/>
+              </a:defRPr>
+            </a:pPr>
+            <a:r>
+              <a:t>Пропсы — данные от родителя к ребёнку через атрибуты JSX. Только для чтения в дочернем компоненте.</a:t>
             </a:r>
           </a:p>
           <a:p>
             <a:pPr>
               <a:spcAft>
-                <a:spcPts val="1200"/>
+                <a:spcPts val="800"/>
               </a:spcAft>
-              <a:defRPr sz="2200">
-                <a:solidFill>
-                  <a:srgbClr val="333333"/>
-                </a:solidFill>
-                <a:latin typeface="Arial"/>
-              </a:defRPr>
-            </a:pPr>
-            <a:r>
-              <a:t>Всегда три состояния:</a:t>
-            </a:r>
-          </a:p>
-          <a:p>
-            <a:pPr lvl="1">
+              <a:defRPr sz="2000">
+                <a:solidFill>
+                  <a:srgbClr val="FFFFFF"/>
+                </a:solidFill>
+                <a:latin typeface="Times New Roman"/>
+              </a:defRPr>
+            </a:pPr>
+            <a:r>
+              <a:t>Однонаправленный поток: данные текут сверху вниз — от родителя к потомкам. Это делает приложение предсказуемым.</a:t>
+            </a:r>
+          </a:p>
+          <a:p>
+            <a:pPr>
               <a:spcAft>
-                <a:spcPts val="1200"/>
+                <a:spcPts val="800"/>
               </a:spcAft>
-              <a:defRPr sz="2200">
-                <a:solidFill>
-                  <a:srgbClr val="333333"/>
-                </a:solidFill>
-                <a:latin typeface="Arial"/>
-              </a:defRPr>
-            </a:pPr>
-            <a:r>
-              <a:t>  → загрузка — спиннер / скелетон.</a:t>
-            </a:r>
-          </a:p>
-          <a:p>
-            <a:pPr lvl="1">
+              <a:defRPr sz="2000">
+                <a:solidFill>
+                  <a:srgbClr val="FFFFFF"/>
+                </a:solidFill>
+                <a:latin typeface="Times New Roman"/>
+              </a:defRPr>
+            </a:pPr>
+            <a:endParaRPr/>
+          </a:p>
+          <a:p>
+            <a:pPr>
               <a:spcAft>
-                <a:spcPts val="1200"/>
+                <a:spcPts val="800"/>
               </a:spcAft>
-              <a:defRPr sz="2200">
-                <a:solidFill>
-                  <a:srgbClr val="333333"/>
-                </a:solidFill>
-                <a:latin typeface="Arial"/>
-              </a:defRPr>
-            </a:pPr>
-            <a:r>
-              <a:t>  → данные — показываем контент.</a:t>
-            </a:r>
-          </a:p>
-          <a:p>
-            <a:pPr lvl="1">
+              <a:defRPr sz="2000">
+                <a:solidFill>
+                  <a:srgbClr val="FFFFFF"/>
+                </a:solidFill>
+                <a:latin typeface="Times New Roman"/>
+              </a:defRPr>
+            </a:pPr>
+            <a:r>
+              <a:t>Деструктуризация: const { name, age } = props</a:t>
+            </a:r>
+          </a:p>
+          <a:p>
+            <a:pPr>
               <a:spcAft>
-                <a:spcPts val="1200"/>
+                <a:spcPts val="800"/>
               </a:spcAft>
-              <a:defRPr sz="2200">
-                <a:solidFill>
-                  <a:srgbClr val="333333"/>
-                </a:solidFill>
-                <a:latin typeface="Arial"/>
-              </a:defRPr>
-            </a:pPr>
-            <a:r>
-              <a:t>  → ошибка — понятное сообщение, а не белый экран.</a:t>
+              <a:defRPr sz="2000">
+                <a:solidFill>
+                  <a:srgbClr val="FFFFFF"/>
+                </a:solidFill>
+                <a:latin typeface="Times New Roman"/>
+              </a:defRPr>
+            </a:pPr>
+            <a:r>
+              <a:t>Значения по умолчанию: function Button({ text = 'Нажми' })</a:t>
             </a:r>
           </a:p>
           <a:p>
             <a:pPr>
               <a:spcAft>
-                <a:spcPts val="1200"/>
+                <a:spcPts val="800"/>
               </a:spcAft>
-              <a:defRPr sz="2200">
-                <a:solidFill>
-                  <a:srgbClr val="333333"/>
-                </a:solidFill>
-                <a:latin typeface="Arial"/>
-              </a:defRPr>
-            </a:pPr>
-            <a:r>
-              <a:t>Отменяй запрос при уходе со страницы — AbortController.</a:t>
+              <a:defRPr sz="2000">
+                <a:solidFill>
+                  <a:srgbClr val="FFFFFF"/>
+                </a:solidFill>
+                <a:latin typeface="Times New Roman"/>
+              </a:defRPr>
+            </a:pPr>
+            <a:r>
+              <a:t>Подъём состояния: если компоненты разделяют данные — состояние поднимается к общему предку.</a:t>
+            </a:r>
+          </a:p>
+        </p:txBody>
+      </p:sp>
+      <p:sp>
+        <p:nvSpPr>
+          <p:cNvPr id="4" name="Rectangle 3"/>
+          <p:cNvSpPr/>
+          <p:nvPr/>
+        </p:nvSpPr>
+        <p:spPr>
+          <a:xfrm>
+            <a:off x="457200" y="4572000"/>
+            <a:ext cx="11247120" cy="1828800"/>
+          </a:xfrm>
+          <a:prstGeom prst="rect">
+            <a:avLst/>
+          </a:prstGeom>
+          <a:solidFill>
+            <a:srgbClr val="020617"/>
+          </a:solidFill>
+          <a:ln>
+            <a:noFill/>
+          </a:ln>
+        </p:spPr>
+        <p:style>
+          <a:lnRef idx="1">
+            <a:schemeClr val="accent1"/>
+          </a:lnRef>
+          <a:fillRef idx="3">
+            <a:schemeClr val="accent1"/>
+          </a:fillRef>
+          <a:effectRef idx="2">
+            <a:schemeClr val="accent1"/>
+          </a:effectRef>
+          <a:fontRef idx="minor">
+            <a:schemeClr val="lt1"/>
+          </a:fontRef>
+        </p:style>
+        <p:txBody>
+          <a:bodyPr rtlCol="0" anchor="ctr"/>
+          <a:lstStyle/>
+          <a:p>
+            <a:pPr algn="ctr"/>
+            <a:endParaRPr/>
+          </a:p>
+        </p:txBody>
+      </p:sp>
+      <p:sp>
+        <p:nvSpPr>
+          <p:cNvPr id="5" name="TextBox 4"/>
+          <p:cNvSpPr txBox="1"/>
+          <p:nvPr/>
+        </p:nvSpPr>
+        <p:spPr>
+          <a:xfrm>
+            <a:off x="640080" y="4663440"/>
+            <a:ext cx="10881360" cy="1645920"/>
+          </a:xfrm>
+          <a:prstGeom prst="rect">
+            <a:avLst/>
+          </a:prstGeom>
+          <a:noFill/>
+        </p:spPr>
+        <p:txBody>
+          <a:bodyPr wrap="square">
+            <a:spAutoFit/>
+          </a:bodyPr>
+          <a:lstStyle/>
+          <a:p>
+            <a:pPr>
+              <a:defRPr sz="1400">
+                <a:solidFill>
+                  <a:srgbClr val="34D399"/>
+                </a:solidFill>
+                <a:latin typeface="Consolas"/>
+              </a:defRPr>
+            </a:pPr>
+            <a:r>
+              <a:t>&lt;Child name="Ivan" age={25} /&gt;</a:t>
+            </a:r>
+            <a:br/>
+            <a:r>
+              <a:t/>
+            </a:r>
+            <a:br/>
+            <a:r>
+              <a:t>const { name, age } = props;</a:t>
+            </a:r>
+            <a:br/>
+            <a:r>
+              <a:t>function Button({ text = "Нажми" }) {}</a:t>
+            </a:r>
+          </a:p>
+        </p:txBody>
+      </p:sp>
+    </p:spTree>
+  </p:cSld>
+  <p:clrMapOvr>
+    <a:masterClrMapping/>
+  </p:clrMapOvr>
+</p:sld>
+</file>
+
+<file path=ppt/slides/slide8.xml><?xml version="1.0" encoding="utf-8"?>
+<p:sld xmlns:a="http://schemas.openxmlformats.org/drawingml/2006/main" xmlns:r="http://schemas.openxmlformats.org/officeDocument/2006/relationships" xmlns:p="http://schemas.openxmlformats.org/presentationml/2006/main">
+  <p:cSld>
+    <p:bg>
+      <p:bgPr>
+        <a:solidFill>
+          <a:srgbClr val="0F172A"/>
+        </a:solidFill>
+        <a:effectLst/>
+      </p:bgPr>
+    </p:bg>
+    <p:spTree>
+      <p:nvGrpSpPr>
+        <p:cNvPr id="1" name=""/>
+        <p:cNvGrpSpPr/>
+        <p:nvPr/>
+      </p:nvGrpSpPr>
+      <p:grpSpPr>
+        <a:xfrm>
+          <a:off x="0" y="0"/>
+          <a:ext cx="0" cy="0"/>
+          <a:chOff x="0" y="0"/>
+          <a:chExt cx="0" cy="0"/>
+        </a:xfrm>
+      </p:grpSpPr>
+      <p:sp>
+        <p:nvSpPr>
+          <p:cNvPr id="2" name="TextBox 1"/>
+          <p:cNvSpPr txBox="1"/>
+          <p:nvPr/>
+        </p:nvSpPr>
+        <p:spPr>
+          <a:xfrm>
+            <a:off x="457200" y="365760"/>
+            <a:ext cx="11247120" cy="731520"/>
+          </a:xfrm>
+          <a:prstGeom prst="rect">
+            <a:avLst/>
+          </a:prstGeom>
+          <a:noFill/>
+        </p:spPr>
+        <p:txBody>
+          <a:bodyPr wrap="none">
+            <a:spAutoFit/>
+          </a:bodyPr>
+          <a:lstStyle/>
+          <a:p>
+            <a:pPr algn="l">
+              <a:defRPr sz="3200" b="1">
+                <a:solidFill>
+                  <a:srgbClr val="38BDF8"/>
+                </a:solidFill>
+                <a:latin typeface="Times New Roman"/>
+              </a:defRPr>
+            </a:pPr>
+            <a:r>
+              <a:t>6. Хук useState</a:t>
+            </a:r>
+          </a:p>
+        </p:txBody>
+      </p:sp>
+      <p:sp>
+        <p:nvSpPr>
+          <p:cNvPr id="3" name="TextBox 2"/>
+          <p:cNvSpPr txBox="1"/>
+          <p:nvPr/>
+        </p:nvSpPr>
+        <p:spPr>
+          <a:xfrm>
+            <a:off x="457200" y="1097280"/>
+            <a:ext cx="11247120" cy="5303520"/>
+          </a:xfrm>
+          <a:prstGeom prst="rect">
+            <a:avLst/>
+          </a:prstGeom>
+          <a:noFill/>
+        </p:spPr>
+        <p:txBody>
+          <a:bodyPr wrap="square">
+            <a:spAutoFit/>
+          </a:bodyPr>
+          <a:lstStyle/>
+          <a:p>
+            <a:pPr>
+              <a:spcAft>
+                <a:spcPts val="800"/>
+              </a:spcAft>
+              <a:defRPr sz="1800">
+                <a:solidFill>
+                  <a:srgbClr val="FFFFFF"/>
+                </a:solidFill>
+                <a:latin typeface="Times New Roman"/>
+              </a:defRPr>
+            </a:pPr>
+            <a:r>
+              <a:t>useState — хук для добавления состояния в функциональные компоненты. Возвращает [значение, установщик].</a:t>
+            </a:r>
+          </a:p>
+          <a:p>
+            <a:pPr>
+              <a:spcAft>
+                <a:spcPts val="800"/>
+              </a:spcAft>
+              <a:defRPr sz="1800">
+                <a:solidFill>
+                  <a:srgbClr val="FFFFFF"/>
+                </a:solidFill>
+                <a:latin typeface="Times New Roman"/>
+              </a:defRPr>
+            </a:pPr>
+            <a:endParaRPr/>
+          </a:p>
+          <a:p>
+            <a:pPr>
+              <a:spcAft>
+                <a:spcPts val="800"/>
+              </a:spcAft>
+              <a:defRPr sz="1800">
+                <a:solidFill>
+                  <a:srgbClr val="FFFFFF"/>
+                </a:solidFill>
+                <a:latin typeface="Times New Roman"/>
+              </a:defRPr>
+            </a:pPr>
+            <a:r>
+              <a:t>Состояние vs пропсы: пропсы — внешние, состояние — внутренние.</a:t>
+            </a:r>
+          </a:p>
+          <a:p>
+            <a:pPr>
+              <a:spcAft>
+                <a:spcPts val="800"/>
+              </a:spcAft>
+              <a:defRPr sz="1800">
+                <a:solidFill>
+                  <a:srgbClr val="FFFFFF"/>
+                </a:solidFill>
+                <a:latin typeface="Times New Roman"/>
+              </a:defRPr>
+            </a:pPr>
+            <a:r>
+              <a:t>Асинхронность: React группирует обновления. Сразу после setCount() значение ещё старое.</a:t>
+            </a:r>
+          </a:p>
+          <a:p>
+            <a:pPr>
+              <a:spcAft>
+                <a:spcPts val="800"/>
+              </a:spcAft>
+              <a:defRPr sz="1800">
+                <a:solidFill>
+                  <a:srgbClr val="FFFFFF"/>
+                </a:solidFill>
+                <a:latin typeface="Times New Roman"/>
+              </a:defRPr>
+            </a:pPr>
+            <a:r>
+              <a:t>Функция-обновитель: вместо setCount(count + 1) используйте setCount(prev =&gt; prev + 1).</a:t>
+            </a:r>
+          </a:p>
+        </p:txBody>
+      </p:sp>
+      <p:sp>
+        <p:nvSpPr>
+          <p:cNvPr id="4" name="Rectangle 3"/>
+          <p:cNvSpPr/>
+          <p:nvPr/>
+        </p:nvSpPr>
+        <p:spPr>
+          <a:xfrm>
+            <a:off x="457200" y="4114800"/>
+            <a:ext cx="11247120" cy="1828800"/>
+          </a:xfrm>
+          <a:prstGeom prst="rect">
+            <a:avLst/>
+          </a:prstGeom>
+          <a:solidFill>
+            <a:srgbClr val="020617"/>
+          </a:solidFill>
+          <a:ln>
+            <a:noFill/>
+          </a:ln>
+        </p:spPr>
+        <p:style>
+          <a:lnRef idx="1">
+            <a:schemeClr val="accent1"/>
+          </a:lnRef>
+          <a:fillRef idx="3">
+            <a:schemeClr val="accent1"/>
+          </a:fillRef>
+          <a:effectRef idx="2">
+            <a:schemeClr val="accent1"/>
+          </a:effectRef>
+          <a:fontRef idx="minor">
+            <a:schemeClr val="lt1"/>
+          </a:fontRef>
+        </p:style>
+        <p:txBody>
+          <a:bodyPr rtlCol="0" anchor="ctr"/>
+          <a:lstStyle/>
+          <a:p>
+            <a:pPr algn="ctr"/>
+            <a:endParaRPr/>
+          </a:p>
+        </p:txBody>
+      </p:sp>
+      <p:sp>
+        <p:nvSpPr>
+          <p:cNvPr id="5" name="TextBox 4"/>
+          <p:cNvSpPr txBox="1"/>
+          <p:nvPr/>
+        </p:nvSpPr>
+        <p:spPr>
+          <a:xfrm>
+            <a:off x="640080" y="4206240"/>
+            <a:ext cx="10881360" cy="1645920"/>
+          </a:xfrm>
+          <a:prstGeom prst="rect">
+            <a:avLst/>
+          </a:prstGeom>
+          <a:noFill/>
+        </p:spPr>
+        <p:txBody>
+          <a:bodyPr wrap="square">
+            <a:spAutoFit/>
+          </a:bodyPr>
+          <a:lstStyle/>
+          <a:p>
+            <a:pPr>
+              <a:defRPr sz="1400">
+                <a:solidFill>
+                  <a:srgbClr val="34D399"/>
+                </a:solidFill>
+                <a:latin typeface="Consolas"/>
+              </a:defRPr>
+            </a:pPr>
+            <a:r>
+              <a:t>const [count, setCount] = useState(0);</a:t>
+            </a:r>
+          </a:p>
+        </p:txBody>
+      </p:sp>
+      <p:sp>
+        <p:nvSpPr>
+          <p:cNvPr id="6" name="Rectangle 5"/>
+          <p:cNvSpPr/>
+          <p:nvPr/>
+        </p:nvSpPr>
+        <p:spPr>
+          <a:xfrm>
+            <a:off x="457200" y="5303520"/>
+            <a:ext cx="91440" cy="914400"/>
+          </a:xfrm>
+          <a:prstGeom prst="rect">
+            <a:avLst/>
+          </a:prstGeom>
+          <a:solidFill>
+            <a:srgbClr val="F87171"/>
+          </a:solidFill>
+          <a:ln>
+            <a:noFill/>
+          </a:ln>
+        </p:spPr>
+        <p:style>
+          <a:lnRef idx="1">
+            <a:schemeClr val="accent1"/>
+          </a:lnRef>
+          <a:fillRef idx="3">
+            <a:schemeClr val="accent1"/>
+          </a:fillRef>
+          <a:effectRef idx="2">
+            <a:schemeClr val="accent1"/>
+          </a:effectRef>
+          <a:fontRef idx="minor">
+            <a:schemeClr val="lt1"/>
+          </a:fontRef>
+        </p:style>
+        <p:txBody>
+          <a:bodyPr rtlCol="0" anchor="ctr"/>
+          <a:lstStyle/>
+          <a:p>
+            <a:pPr algn="ctr"/>
+            <a:endParaRPr/>
+          </a:p>
+        </p:txBody>
+      </p:sp>
+      <p:sp>
+        <p:nvSpPr>
+          <p:cNvPr id="7" name="TextBox 6"/>
+          <p:cNvSpPr txBox="1"/>
+          <p:nvPr/>
+        </p:nvSpPr>
+        <p:spPr>
+          <a:xfrm>
+            <a:off x="640080" y="5303520"/>
+            <a:ext cx="10972800" cy="914400"/>
+          </a:xfrm>
+          <a:prstGeom prst="rect">
+            <a:avLst/>
+          </a:prstGeom>
+          <a:noFill/>
+        </p:spPr>
+        <p:txBody>
+          <a:bodyPr wrap="square">
+            <a:spAutoFit/>
+          </a:bodyPr>
+          <a:lstStyle/>
+          <a:p>
+            <a:pPr>
+              <a:defRPr sz="1800" b="1">
+                <a:solidFill>
+                  <a:srgbClr val="F87171"/>
+                </a:solidFill>
+                <a:latin typeface="Times New Roman"/>
+              </a:defRPr>
+            </a:pPr>
+            <a:r>
+              <a:t>Ошибка: прямая мутация</a:t>
+            </a:r>
+          </a:p>
+          <a:p>
+            <a:pPr>
+              <a:defRPr sz="1600">
+                <a:solidFill>
+                  <a:srgbClr val="FFFFFF"/>
+                </a:solidFill>
+                <a:latin typeface="Times New Roman"/>
+              </a:defRPr>
+            </a:pPr>
+            <a:r>
+              <a:t>state.push(item) — плохо. React сравнивает по ссылке. Нужно: setState([...state, item]).</a:t>
+            </a:r>
+          </a:p>
+        </p:txBody>
+      </p:sp>
+    </p:spTree>
+  </p:cSld>
+  <p:clrMapOvr>
+    <a:masterClrMapping/>
+  </p:clrMapOvr>
+</p:sld>
+</file>
+
+<file path=ppt/slides/slide9.xml><?xml version="1.0" encoding="utf-8"?>
+<p:sld xmlns:a="http://schemas.openxmlformats.org/drawingml/2006/main" xmlns:r="http://schemas.openxmlformats.org/officeDocument/2006/relationships" xmlns:p="http://schemas.openxmlformats.org/presentationml/2006/main">
+  <p:cSld>
+    <p:bg>
+      <p:bgPr>
+        <a:solidFill>
+          <a:srgbClr val="0F172A"/>
+        </a:solidFill>
+        <a:effectLst/>
+      </p:bgPr>
+    </p:bg>
+    <p:spTree>
+      <p:nvGrpSpPr>
+        <p:cNvPr id="1" name=""/>
+        <p:cNvGrpSpPr/>
+        <p:nvPr/>
+      </p:nvGrpSpPr>
+      <p:grpSpPr>
+        <a:xfrm>
+          <a:off x="0" y="0"/>
+          <a:ext cx="0" cy="0"/>
+          <a:chOff x="0" y="0"/>
+          <a:chExt cx="0" cy="0"/>
+        </a:xfrm>
+      </p:grpSpPr>
+      <p:sp>
+        <p:nvSpPr>
+          <p:cNvPr id="2" name="TextBox 1"/>
+          <p:cNvSpPr txBox="1"/>
+          <p:nvPr/>
+        </p:nvSpPr>
+        <p:spPr>
+          <a:xfrm>
+            <a:off x="457200" y="365760"/>
+            <a:ext cx="11247120" cy="731520"/>
+          </a:xfrm>
+          <a:prstGeom prst="rect">
+            <a:avLst/>
+          </a:prstGeom>
+          <a:noFill/>
+        </p:spPr>
+        <p:txBody>
+          <a:bodyPr wrap="none">
+            <a:spAutoFit/>
+          </a:bodyPr>
+          <a:lstStyle/>
+          <a:p>
+            <a:pPr algn="l">
+              <a:defRPr sz="3200" b="1">
+                <a:solidFill>
+                  <a:srgbClr val="38BDF8"/>
+                </a:solidFill>
+                <a:latin typeface="Times New Roman"/>
+              </a:defRPr>
+            </a:pPr>
+            <a:r>
+              <a:t>7. Хук useEffect</a:t>
+            </a:r>
+          </a:p>
+        </p:txBody>
+      </p:sp>
+      <p:sp>
+        <p:nvSpPr>
+          <p:cNvPr id="3" name="TextBox 2"/>
+          <p:cNvSpPr txBox="1"/>
+          <p:nvPr/>
+        </p:nvSpPr>
+        <p:spPr>
+          <a:xfrm>
+            <a:off x="457200" y="1097280"/>
+            <a:ext cx="11247120" cy="5303520"/>
+          </a:xfrm>
+          <a:prstGeom prst="rect">
+            <a:avLst/>
+          </a:prstGeom>
+          <a:noFill/>
+        </p:spPr>
+        <p:txBody>
+          <a:bodyPr wrap="square">
+            <a:spAutoFit/>
+          </a:bodyPr>
+          <a:lstStyle/>
+          <a:p>
+            <a:pPr>
+              <a:spcAft>
+                <a:spcPts val="800"/>
+              </a:spcAft>
+              <a:defRPr sz="1800">
+                <a:solidFill>
+                  <a:srgbClr val="FFFFFF"/>
+                </a:solidFill>
+                <a:latin typeface="Times New Roman"/>
+              </a:defRPr>
+            </a:pPr>
+            <a:r>
+              <a:t>useEffect — хук для побочных эффектов: запросы, подписки, таймеры.</a:t>
+            </a:r>
+          </a:p>
+          <a:p>
+            <a:pPr>
+              <a:spcAft>
+                <a:spcPts val="800"/>
+              </a:spcAft>
+              <a:defRPr sz="1800">
+                <a:solidFill>
+                  <a:srgbClr val="FFFFFF"/>
+                </a:solidFill>
+                <a:latin typeface="Times New Roman"/>
+              </a:defRPr>
+            </a:pPr>
+            <a:endParaRPr/>
+          </a:p>
+          <a:p>
+            <a:pPr>
+              <a:spcAft>
+                <a:spcPts val="800"/>
+              </a:spcAft>
+              <a:defRPr sz="1800">
+                <a:solidFill>
+                  <a:srgbClr val="FFFFFF"/>
+                </a:solidFill>
+                <a:latin typeface="Times New Roman"/>
+              </a:defRPr>
+            </a:pPr>
+            <a:r>
+              <a:t>Массив зависимостей:</a:t>
+            </a:r>
+          </a:p>
+          <a:p>
+            <a:pPr>
+              <a:spcAft>
+                <a:spcPts val="800"/>
+              </a:spcAft>
+              <a:defRPr sz="1800">
+                <a:solidFill>
+                  <a:srgbClr val="FFFFFF"/>
+                </a:solidFill>
+                <a:latin typeface="Times New Roman"/>
+              </a:defRPr>
+            </a:pPr>
+            <a:r>
+              <a:t>  • Нет массива — после каждого рендера (редко)</a:t>
+            </a:r>
+          </a:p>
+          <a:p>
+            <a:pPr>
+              <a:spcAft>
+                <a:spcPts val="800"/>
+              </a:spcAft>
+              <a:defRPr sz="1800">
+                <a:solidFill>
+                  <a:srgbClr val="FFFFFF"/>
+                </a:solidFill>
+                <a:latin typeface="Times New Roman"/>
+              </a:defRPr>
+            </a:pPr>
+            <a:r>
+              <a:t>  • [] — только при монтировании (загрузка данных)</a:t>
+            </a:r>
+          </a:p>
+          <a:p>
+            <a:pPr>
+              <a:spcAft>
+                <a:spcPts val="800"/>
+              </a:spcAft>
+              <a:defRPr sz="1800">
+                <a:solidFill>
+                  <a:srgbClr val="FFFFFF"/>
+                </a:solidFill>
+                <a:latin typeface="Times New Roman"/>
+              </a:defRPr>
+            </a:pPr>
+            <a:r>
+              <a:t>  • [userId] — при монтировании и изменении зависимости</a:t>
+            </a:r>
+          </a:p>
+          <a:p>
+            <a:pPr>
+              <a:spcAft>
+                <a:spcPts val="800"/>
+              </a:spcAft>
+              <a:defRPr sz="1800">
+                <a:solidFill>
+                  <a:srgbClr val="FFFFFF"/>
+                </a:solidFill>
+                <a:latin typeface="Times New Roman"/>
+              </a:defRPr>
+            </a:pPr>
+            <a:endParaRPr/>
+          </a:p>
+          <a:p>
+            <a:pPr>
+              <a:spcAft>
+                <a:spcPts val="800"/>
+              </a:spcAft>
+              <a:defRPr sz="1800">
+                <a:solidFill>
+                  <a:srgbClr val="FFFFFF"/>
+                </a:solidFill>
+                <a:latin typeface="Times New Roman"/>
+              </a:defRPr>
+            </a:pPr>
+            <a:r>
+              <a:t>Cleanup: функция, которую возвращает эффект. Отменяет подписки, таймеры при размонтировании. Без неё — утечки памяти.</a:t>
+            </a:r>
+          </a:p>
+        </p:txBody>
+      </p:sp>
+      <p:sp>
+        <p:nvSpPr>
+          <p:cNvPr id="4" name="Rectangle 3"/>
+          <p:cNvSpPr/>
+          <p:nvPr/>
+        </p:nvSpPr>
+        <p:spPr>
+          <a:xfrm>
+            <a:off x="457200" y="5303520"/>
+            <a:ext cx="91440" cy="914400"/>
+          </a:xfrm>
+          <a:prstGeom prst="rect">
+            <a:avLst/>
+          </a:prstGeom>
+          <a:solidFill>
+            <a:srgbClr val="F87171"/>
+          </a:solidFill>
+          <a:ln>
+            <a:noFill/>
+          </a:ln>
+        </p:spPr>
+        <p:style>
+          <a:lnRef idx="1">
+            <a:schemeClr val="accent1"/>
+          </a:lnRef>
+          <a:fillRef idx="3">
+            <a:schemeClr val="accent1"/>
+          </a:fillRef>
+          <a:effectRef idx="2">
+            <a:schemeClr val="accent1"/>
+          </a:effectRef>
+          <a:fontRef idx="minor">
+            <a:schemeClr val="lt1"/>
+          </a:fontRef>
+        </p:style>
+        <p:txBody>
+          <a:bodyPr rtlCol="0" anchor="ctr"/>
+          <a:lstStyle/>
+          <a:p>
+            <a:pPr algn="ctr"/>
+            <a:endParaRPr/>
+          </a:p>
+        </p:txBody>
+      </p:sp>
+      <p:sp>
+        <p:nvSpPr>
+          <p:cNvPr id="5" name="TextBox 4"/>
+          <p:cNvSpPr txBox="1"/>
+          <p:nvPr/>
+        </p:nvSpPr>
+        <p:spPr>
+          <a:xfrm>
+            <a:off x="640080" y="5303520"/>
+            <a:ext cx="10972800" cy="914400"/>
+          </a:xfrm>
+          <a:prstGeom prst="rect">
+            <a:avLst/>
+          </a:prstGeom>
+          <a:noFill/>
+        </p:spPr>
+        <p:txBody>
+          <a:bodyPr wrap="square">
+            <a:spAutoFit/>
+          </a:bodyPr>
+          <a:lstStyle/>
+          <a:p>
+            <a:pPr>
+              <a:defRPr sz="1800" b="1">
+                <a:solidFill>
+                  <a:srgbClr val="F87171"/>
+                </a:solidFill>
+                <a:latin typeface="Times New Roman"/>
+              </a:defRPr>
+            </a:pPr>
+            <a:r>
+              <a:t>Ошибка: бесконечный цикл</a:t>
+            </a:r>
+          </a:p>
+          <a:p>
+            <a:pPr>
+              <a:defRPr sz="1600">
+                <a:solidFill>
+                  <a:srgbClr val="FFFFFF"/>
+                </a:solidFill>
+                <a:latin typeface="Times New Roman"/>
+              </a:defRPr>
+            </a:pPr>
+            <a:r>
+              <a:t>Если внутри useEffect обновляется состояние, которое в deps — эффект запускается снова и снова.</a:t>
             </a:r>
           </a:p>
         </p:txBody>

</xml_diff>